<commit_message>
docs: AI 자동화 성장 로드맵 슬라이드 추가 (MCP/Skill/Agent/Plugin)
Slide 33 추가: Lv.1 대화형 → Lv.2 MCP+Skill → Lv.3 Agent+Plugin → Lv.4 조직 통합

Co-Authored-By: Claude Opus 4.6 <noreply@anthropic.com>
</commit_message>
<xml_diff>
--- a/projects/26Q3_Fastcampus-Lecture/assets/pptx/ai-native-pm-lecture.pptx
+++ b/projects/26Q3_Fastcampus-Lecture/assets/pptx/ai-native-pm-lecture.pptx
@@ -5,7 +5,7 @@
     <p:sldMasterId id="2147483648" r:id="rId1"/>
   </p:sldMasterIdLst>
   <p:notesMasterIdLst>
-    <p:notesMasterId r:id="rId35"/>
+    <p:notesMasterId r:id="rId36"/>
   </p:notesMasterIdLst>
   <p:sldIdLst>
     <p:sldId id="256" r:id="rId2"/>
@@ -41,6 +41,7 @@
     <p:sldId id="286" r:id="rId32"/>
     <p:sldId id="287" r:id="rId33"/>
     <p:sldId id="288" r:id="rId34"/>
+    <p:sldId id="289" r:id="rId35"/>
   </p:sldIdLst>
   <p:sldSz cx="9144000" cy="5143500" type="screen16x9"/>
   <p:notesSz cx="5143500" cy="9144000"/>
@@ -169,7 +170,7 @@
     </p:spTree>
     <p:extLst>
       <p:ext uri="{BB962C8B-B14F-4D97-AF65-F5344CB8AC3E}">
-        <p14:creationId xmlns:p14="http://schemas.microsoft.com/office/powerpoint/2010/main" val="975234517"/>
+        <p14:creationId xmlns:p14="http://schemas.microsoft.com/office/powerpoint/2010/main" val="2849614392"/>
       </p:ext>
     </p:extLst>
   </p:cSld>
@@ -2519,6 +2520,90 @@
             <a:fld id="{F7021451-1387-4CA6-816F-3879F97B5CBC}" type="slidenum">
               <a:rPr lang="en-US"/>
               <a:t>33</a:t>
+            </a:fld>
+            <a:endParaRPr lang="en-US"/>
+          </a:p>
+        </p:txBody>
+      </p:sp>
+    </p:spTree>
+    <p:extLst>
+      <p:ext uri="{BB962C8B-B14F-4D97-AF65-F5344CB8AC3E}">
+        <p14:creationId xmlns:p14="http://schemas.microsoft.com/office/powerpoint/2010/main" val="1024086991"/>
+      </p:ext>
+    </p:extLst>
+  </p:cSld>
+  <p:clrMapOvr>
+    <a:masterClrMapping/>
+  </p:clrMapOvr>
+</p:notes>
+</file>
+
+<file path=ppt/notesSlides/notesSlide34.xml><?xml version="1.0" encoding="utf-8"?>
+<p:notes xmlns:a="http://schemas.openxmlformats.org/drawingml/2006/main" xmlns:r="http://schemas.openxmlformats.org/officeDocument/2006/relationships" xmlns:p="http://schemas.openxmlformats.org/presentationml/2006/main">
+  <p:cSld>
+    <p:spTree>
+      <p:nvGrpSpPr>
+        <p:cNvPr id="1" name=""/>
+        <p:cNvGrpSpPr/>
+        <p:nvPr/>
+      </p:nvGrpSpPr>
+      <p:grpSpPr>
+        <a:xfrm>
+          <a:off x="0" y="0"/>
+          <a:ext cx="0" cy="0"/>
+          <a:chOff x="0" y="0"/>
+          <a:chExt cx="0" cy="0"/>
+        </a:xfrm>
+      </p:grpSpPr>
+      <p:sp>
+        <p:nvSpPr>
+          <p:cNvPr id="2" name="Slide Image Placeholder 1"/>
+          <p:cNvSpPr>
+            <a:spLocks noGrp="1" noRot="1" noChangeAspect="1"/>
+          </p:cNvSpPr>
+          <p:nvPr>
+            <p:ph type="sldImg"/>
+          </p:nvPr>
+        </p:nvSpPr>
+        <p:spPr/>
+      </p:sp>
+      <p:sp>
+        <p:nvSpPr>
+          <p:cNvPr id="3" name="Notes Placeholder 2"/>
+          <p:cNvSpPr>
+            <a:spLocks noGrp="1"/>
+          </p:cNvSpPr>
+          <p:nvPr>
+            <p:ph type="body" idx="1"/>
+          </p:nvPr>
+        </p:nvSpPr>
+        <p:spPr/>
+        <p:txBody>
+          <a:bodyPr/>
+          <a:lstStyle/>
+          <a:p>
+            <a:endParaRPr lang="en-US" dirty="0"/>
+          </a:p>
+        </p:txBody>
+      </p:sp>
+      <p:sp>
+        <p:nvSpPr>
+          <p:cNvPr id="4" name="Slide Number Placeholder 3"/>
+          <p:cNvSpPr>
+            <a:spLocks noGrp="1"/>
+          </p:cNvSpPr>
+          <p:nvPr>
+            <p:ph type="sldNum" sz="quarter" idx="10"/>
+          </p:nvPr>
+        </p:nvSpPr>
+        <p:spPr/>
+        <p:txBody>
+          <a:bodyPr/>
+          <a:lstStyle/>
+          <a:p>
+            <a:fld id="{F7021451-1387-4CA6-816F-3879F97B5CBC}" type="slidenum">
+              <a:rPr lang="en-US"/>
+              <a:t>34</a:t>
             </a:fld>
             <a:endParaRPr lang="en-US"/>
           </a:p>
@@ -3514,8 +3599,8 @@
         </p:nvSpPr>
         <p:spPr>
           <a:xfrm>
-            <a:off x="640080" y="3633052"/>
-            <a:ext cx="7863840" cy="801788"/>
+            <a:off x="640080" y="4114800"/>
+            <a:ext cx="7863840" cy="320040"/>
           </a:xfrm>
           <a:prstGeom prst="rect">
             <a:avLst/>
@@ -3539,229 +3624,9 @@
                 <a:ea typeface="NanumGothic" pitchFamily="34" charset="-122"/>
                 <a:cs typeface="NanumGothic" pitchFamily="34" charset="-120"/>
               </a:rPr>
-              <a:t>FastCampus  </a:t>
-            </a:r>
-            <a:r>
-              <a:rPr lang="en-US" sz="1300">
-                <a:solidFill>
-                  <a:srgbClr val="FF6B35"/>
-                </a:solidFill>
-                <a:latin typeface="NanumGothic" pitchFamily="34" charset="0"/>
-                <a:ea typeface="NanumGothic" pitchFamily="34" charset="-122"/>
-                <a:cs typeface="NanumGothic" pitchFamily="34" charset="-120"/>
-              </a:rPr>
-              <a:t>|  2026.04.1</a:t>
-            </a:r>
-            <a:r>
-              <a:rPr lang="en-US" altLang="ko-KR" sz="1300">
-                <a:solidFill>
-                  <a:srgbClr val="FF6B35"/>
-                </a:solidFill>
-                <a:latin typeface="NanumGothic" pitchFamily="34" charset="0"/>
-                <a:ea typeface="NanumGothic" pitchFamily="34" charset="-122"/>
-                <a:cs typeface="NanumGothic" pitchFamily="34" charset="-120"/>
-              </a:rPr>
-              <a:t>7</a:t>
-            </a:r>
-            <a:r>
-              <a:rPr lang="en-US" sz="1300">
-                <a:solidFill>
-                  <a:srgbClr val="FF6B35"/>
-                </a:solidFill>
-                <a:latin typeface="NanumGothic" pitchFamily="34" charset="0"/>
-                <a:ea typeface="NanumGothic" pitchFamily="34" charset="-122"/>
-                <a:cs typeface="NanumGothic" pitchFamily="34" charset="-120"/>
-              </a:rPr>
-              <a:t>  </a:t>
-            </a:r>
-            <a:r>
-              <a:rPr lang="en-US" sz="1300" dirty="0">
-                <a:solidFill>
-                  <a:srgbClr val="FF6B35"/>
-                </a:solidFill>
-                <a:latin typeface="NanumGothic" pitchFamily="34" charset="0"/>
-                <a:ea typeface="NanumGothic" pitchFamily="34" charset="-122"/>
-                <a:cs typeface="NanumGothic" pitchFamily="34" charset="-120"/>
-              </a:rPr>
-              <a:t>|  				</a:t>
-            </a:r>
-            <a:r>
-              <a:rPr lang="ko-KR" altLang="en-US" sz="1300" dirty="0">
-                <a:solidFill>
-                  <a:srgbClr val="FF6B35"/>
-                </a:solidFill>
-                <a:latin typeface="NanumGothic" pitchFamily="34" charset="0"/>
-                <a:ea typeface="NanumGothic" pitchFamily="34" charset="-122"/>
-                <a:cs typeface="NanumGothic" pitchFamily="34" charset="-120"/>
-              </a:rPr>
-              <a:t>                                         </a:t>
-            </a:r>
-            <a:r>
-              <a:rPr lang="en-US" sz="1300" dirty="0">
-                <a:solidFill>
-                  <a:srgbClr val="FF6B35"/>
-                </a:solidFill>
-                <a:latin typeface="NanumGothic" pitchFamily="34" charset="0"/>
-                <a:ea typeface="NanumGothic" pitchFamily="34" charset="-122"/>
-                <a:cs typeface="NanumGothic" pitchFamily="34" charset="-120"/>
-              </a:rPr>
-              <a:t>차성재</a:t>
-            </a:r>
-            <a:r>
-              <a:rPr lang="ko-KR" altLang="en-US" sz="1300" dirty="0">
-                <a:solidFill>
-                  <a:srgbClr val="FF6B35"/>
-                </a:solidFill>
-                <a:latin typeface="NanumGothic" pitchFamily="34" charset="0"/>
-                <a:ea typeface="NanumGothic" pitchFamily="34" charset="-122"/>
-                <a:cs typeface="NanumGothic" pitchFamily="34" charset="-120"/>
-              </a:rPr>
-              <a:t> </a:t>
-            </a:r>
-            <a:endParaRPr lang="en-US" altLang="ko-KR" sz="1300" dirty="0">
-              <a:solidFill>
-                <a:srgbClr val="FF6B35"/>
-              </a:solidFill>
-              <a:latin typeface="NanumGothic" pitchFamily="34" charset="0"/>
-              <a:ea typeface="NanumGothic" pitchFamily="34" charset="-122"/>
-              <a:cs typeface="NanumGothic" pitchFamily="34" charset="-120"/>
-            </a:endParaRPr>
-          </a:p>
-          <a:p>
-            <a:pPr marL="0" indent="0" algn="r">
-              <a:buNone/>
-            </a:pPr>
-            <a:r>
-              <a:rPr lang="en-US" altLang="ko-KR" sz="1300" dirty="0">
-                <a:solidFill>
-                  <a:srgbClr val="FF6B35"/>
-                </a:solidFill>
-                <a:latin typeface="NanumGothic" pitchFamily="34" charset="0"/>
-                <a:ea typeface="NanumGothic" pitchFamily="34" charset="-122"/>
-                <a:cs typeface="NanumGothic" pitchFamily="34" charset="-120"/>
-              </a:rPr>
-              <a:t>Agentic AI PM @ </a:t>
-            </a:r>
-            <a:r>
-              <a:rPr lang="ko-KR" altLang="en-US" sz="1300" dirty="0" err="1">
-                <a:solidFill>
-                  <a:srgbClr val="FF6B35"/>
-                </a:solidFill>
-                <a:latin typeface="NanumGothic" pitchFamily="34" charset="0"/>
-                <a:ea typeface="NanumGothic" pitchFamily="34" charset="-122"/>
-                <a:cs typeface="NanumGothic" pitchFamily="34" charset="-120"/>
-              </a:rPr>
-              <a:t>무신사</a:t>
-            </a:r>
-            <a:endParaRPr lang="en-US" altLang="ko-KR" sz="1300" dirty="0">
-              <a:solidFill>
-                <a:srgbClr val="FF6B35"/>
-              </a:solidFill>
-              <a:latin typeface="NanumGothic" pitchFamily="34" charset="0"/>
-              <a:ea typeface="NanumGothic" pitchFamily="34" charset="-122"/>
-              <a:cs typeface="NanumGothic" pitchFamily="34" charset="-120"/>
-            </a:endParaRPr>
-          </a:p>
-          <a:p>
-            <a:pPr marL="0" indent="0" algn="r">
-              <a:buNone/>
-            </a:pPr>
-            <a:r>
-              <a:rPr lang="en-US" altLang="ko-KR" sz="1300" dirty="0">
-                <a:solidFill>
-                  <a:srgbClr val="FF6B35"/>
-                </a:solidFill>
-                <a:latin typeface="NanumGothic" pitchFamily="34" charset="0"/>
-                <a:ea typeface="NanumGothic" pitchFamily="34" charset="-122"/>
-                <a:cs typeface="NanumGothic" pitchFamily="34" charset="-120"/>
-              </a:rPr>
-              <a:t>AI </a:t>
-            </a:r>
-            <a:r>
-              <a:rPr lang="ko-KR" altLang="en-US" sz="1300" dirty="0">
-                <a:solidFill>
-                  <a:srgbClr val="FF6B35"/>
-                </a:solidFill>
-                <a:latin typeface="NanumGothic" pitchFamily="34" charset="0"/>
-                <a:ea typeface="NanumGothic" pitchFamily="34" charset="-122"/>
-                <a:cs typeface="NanumGothic" pitchFamily="34" charset="-120"/>
-              </a:rPr>
-              <a:t>부문 겸임교수 </a:t>
-            </a:r>
-            <a:r>
-              <a:rPr lang="en-US" altLang="ko-KR" sz="1300" dirty="0">
-                <a:solidFill>
-                  <a:srgbClr val="FF6B35"/>
-                </a:solidFill>
-                <a:latin typeface="NanumGothic" pitchFamily="34" charset="0"/>
-                <a:ea typeface="NanumGothic" pitchFamily="34" charset="-122"/>
-                <a:cs typeface="NanumGothic" pitchFamily="34" charset="-120"/>
-              </a:rPr>
-              <a:t>@</a:t>
-            </a:r>
-            <a:r>
-              <a:rPr lang="ko-KR" altLang="en-US" sz="1300" dirty="0">
-                <a:solidFill>
-                  <a:srgbClr val="FF6B35"/>
-                </a:solidFill>
-                <a:latin typeface="NanumGothic" pitchFamily="34" charset="0"/>
-                <a:ea typeface="NanumGothic" pitchFamily="34" charset="-122"/>
-                <a:cs typeface="NanumGothic" pitchFamily="34" charset="-120"/>
-              </a:rPr>
-              <a:t> </a:t>
-            </a:r>
-            <a:r>
-              <a:rPr lang="ko-KR" altLang="en-US" sz="1300" dirty="0" err="1">
-                <a:solidFill>
-                  <a:srgbClr val="FF6B35"/>
-                </a:solidFill>
-                <a:latin typeface="NanumGothic" pitchFamily="34" charset="0"/>
-                <a:ea typeface="NanumGothic" pitchFamily="34" charset="-122"/>
-                <a:cs typeface="NanumGothic" pitchFamily="34" charset="-120"/>
-              </a:rPr>
-              <a:t>시립대</a:t>
-            </a:r>
-            <a:r>
-              <a:rPr lang="ko-KR" altLang="en-US" sz="1300" dirty="0">
-                <a:solidFill>
-                  <a:srgbClr val="FF6B35"/>
-                </a:solidFill>
-                <a:latin typeface="NanumGothic" pitchFamily="34" charset="0"/>
-                <a:ea typeface="NanumGothic" pitchFamily="34" charset="-122"/>
-                <a:cs typeface="NanumGothic" pitchFamily="34" charset="-120"/>
-              </a:rPr>
-              <a:t> </a:t>
-            </a:r>
-            <a:r>
-              <a:rPr lang="en-US" altLang="ko-KR" sz="1300" dirty="0">
-                <a:solidFill>
-                  <a:srgbClr val="FF6B35"/>
-                </a:solidFill>
-                <a:latin typeface="NanumGothic" pitchFamily="34" charset="0"/>
-                <a:ea typeface="NanumGothic" pitchFamily="34" charset="-122"/>
-                <a:cs typeface="NanumGothic" pitchFamily="34" charset="-120"/>
-              </a:rPr>
-              <a:t>&amp;</a:t>
-            </a:r>
-            <a:r>
-              <a:rPr lang="ko-KR" altLang="en-US" sz="1300" dirty="0">
-                <a:solidFill>
-                  <a:srgbClr val="FF6B35"/>
-                </a:solidFill>
-                <a:latin typeface="NanumGothic" pitchFamily="34" charset="0"/>
-                <a:ea typeface="NanumGothic" pitchFamily="34" charset="-122"/>
-                <a:cs typeface="NanumGothic" pitchFamily="34" charset="-120"/>
-              </a:rPr>
-              <a:t> 아주대</a:t>
-            </a:r>
-            <a:endParaRPr lang="en-US" altLang="ko-KR" sz="1300" dirty="0">
-              <a:solidFill>
-                <a:srgbClr val="FF6B35"/>
-              </a:solidFill>
-              <a:latin typeface="NanumGothic" pitchFamily="34" charset="0"/>
-              <a:ea typeface="NanumGothic" pitchFamily="34" charset="-122"/>
-              <a:cs typeface="NanumGothic" pitchFamily="34" charset="-120"/>
-            </a:endParaRPr>
+              <a:t>FastCampus  |  2026.04.16  |  차성재</a:t>
+            </a:r>
+            <a:endParaRPr lang="en-US" sz="1300" dirty="0"/>
           </a:p>
         </p:txBody>
       </p:sp>
@@ -3900,14 +3765,14 @@
           <p:nvPr>
             <p:extLst>
               <p:ext uri="{D42A27DB-BD31-4B8C-83A1-F6EECF244321}">
-                <p14:modId xmlns:p14="http://schemas.microsoft.com/office/powerpoint/2010/main" val="2454403496"/>
+                <p14:modId xmlns:p14="http://schemas.microsoft.com/office/powerpoint/2010/main" val="1579011935"/>
               </p:ext>
             </p:extLst>
           </p:nvPr>
         </p:nvGraphicFramePr>
         <p:xfrm>
-          <a:off x="365760" y="1370683"/>
-          <a:ext cx="8412480" cy="2377440"/>
+          <a:off x="365760" y="1051560"/>
+          <a:ext cx="8412480" cy="914400"/>
         </p:xfrm>
         <a:graphic>
           <a:graphicData uri="http://schemas.openxmlformats.org/drawingml/2006/table">
@@ -5684,7 +5549,7 @@
         </p:nvSpPr>
         <p:spPr>
           <a:xfrm>
-            <a:off x="640080" y="1348897"/>
+            <a:off x="640080" y="1097280"/>
             <a:ext cx="7863840" cy="640080"/>
           </a:xfrm>
           <a:prstGeom prst="rect">
@@ -5711,7 +5576,7 @@
         </p:nvSpPr>
         <p:spPr>
           <a:xfrm>
-            <a:off x="731520" y="1348897"/>
+            <a:off x="731520" y="1097280"/>
             <a:ext cx="457200" cy="640080"/>
           </a:xfrm>
           <a:prstGeom prst="rect">
@@ -5747,7 +5612,7 @@
         </p:nvSpPr>
         <p:spPr>
           <a:xfrm>
-            <a:off x="1371600" y="1348897"/>
+            <a:off x="1371600" y="1097280"/>
             <a:ext cx="1828800" cy="640080"/>
           </a:xfrm>
           <a:prstGeom prst="rect">
@@ -5786,7 +5651,7 @@
         </p:nvSpPr>
         <p:spPr>
           <a:xfrm>
-            <a:off x="3291840" y="1348897"/>
+            <a:off x="3291840" y="1097280"/>
             <a:ext cx="5029200" cy="640080"/>
           </a:xfrm>
           <a:prstGeom prst="rect">
@@ -5848,7 +5713,7 @@
         </p:nvSpPr>
         <p:spPr>
           <a:xfrm>
-            <a:off x="640080" y="2126137"/>
+            <a:off x="640080" y="1874520"/>
             <a:ext cx="7863840" cy="640080"/>
           </a:xfrm>
           <a:prstGeom prst="rect">
@@ -5875,7 +5740,7 @@
         </p:nvSpPr>
         <p:spPr>
           <a:xfrm>
-            <a:off x="731520" y="2126137"/>
+            <a:off x="731520" y="1874520"/>
             <a:ext cx="457200" cy="640080"/>
           </a:xfrm>
           <a:prstGeom prst="rect">
@@ -5911,7 +5776,7 @@
         </p:nvSpPr>
         <p:spPr>
           <a:xfrm>
-            <a:off x="1371600" y="2126137"/>
+            <a:off x="1371600" y="1874520"/>
             <a:ext cx="1828800" cy="640080"/>
           </a:xfrm>
           <a:prstGeom prst="rect">
@@ -5950,7 +5815,7 @@
         </p:nvSpPr>
         <p:spPr>
           <a:xfrm>
-            <a:off x="3291840" y="2126137"/>
+            <a:off x="3291840" y="1874520"/>
             <a:ext cx="5029200" cy="640080"/>
           </a:xfrm>
           <a:prstGeom prst="rect">
@@ -6012,7 +5877,7 @@
         </p:nvSpPr>
         <p:spPr>
           <a:xfrm>
-            <a:off x="640080" y="2903377"/>
+            <a:off x="640080" y="2651760"/>
             <a:ext cx="7863840" cy="640080"/>
           </a:xfrm>
           <a:prstGeom prst="rect">
@@ -6039,7 +5904,7 @@
         </p:nvSpPr>
         <p:spPr>
           <a:xfrm>
-            <a:off x="731520" y="2903377"/>
+            <a:off x="731520" y="2651760"/>
             <a:ext cx="457200" cy="640080"/>
           </a:xfrm>
           <a:prstGeom prst="rect">
@@ -6075,7 +5940,7 @@
         </p:nvSpPr>
         <p:spPr>
           <a:xfrm>
-            <a:off x="1371600" y="2903377"/>
+            <a:off x="1371600" y="2651760"/>
             <a:ext cx="1828800" cy="640080"/>
           </a:xfrm>
           <a:prstGeom prst="rect">
@@ -6114,7 +5979,7 @@
         </p:nvSpPr>
         <p:spPr>
           <a:xfrm>
-            <a:off x="3291840" y="2903377"/>
+            <a:off x="3291840" y="2651760"/>
             <a:ext cx="5029200" cy="640080"/>
           </a:xfrm>
           <a:prstGeom prst="rect">
@@ -6341,7 +6206,7 @@
         </p:nvSpPr>
         <p:spPr>
           <a:xfrm>
-            <a:off x="640080" y="1084244"/>
+            <a:off x="640080" y="1097280"/>
             <a:ext cx="7863840" cy="320040"/>
           </a:xfrm>
           <a:prstGeom prst="rect">
@@ -6383,7 +6248,7 @@
         </p:nvSpPr>
         <p:spPr>
           <a:xfrm>
-            <a:off x="640080" y="1655744"/>
+            <a:off x="640080" y="1097280"/>
             <a:ext cx="411480" cy="384048"/>
           </a:xfrm>
           <a:prstGeom prst="rect">
@@ -6410,7 +6275,7 @@
         </p:nvSpPr>
         <p:spPr>
           <a:xfrm>
-            <a:off x="640080" y="1655744"/>
+            <a:off x="640080" y="1097280"/>
             <a:ext cx="411480" cy="384048"/>
           </a:xfrm>
           <a:prstGeom prst="rect">
@@ -6449,7 +6314,7 @@
         </p:nvSpPr>
         <p:spPr>
           <a:xfrm>
-            <a:off x="1188720" y="1610024"/>
+            <a:off x="1188720" y="1051560"/>
             <a:ext cx="7315200" cy="475488"/>
           </a:xfrm>
           <a:prstGeom prst="rect">
@@ -6476,7 +6341,7 @@
         </p:nvSpPr>
         <p:spPr>
           <a:xfrm>
-            <a:off x="1188720" y="1610024"/>
+            <a:off x="1188720" y="1051560"/>
             <a:ext cx="36576" cy="475488"/>
           </a:xfrm>
           <a:prstGeom prst="rect">
@@ -6503,7 +6368,7 @@
         </p:nvSpPr>
         <p:spPr>
           <a:xfrm>
-            <a:off x="1371600" y="1610024"/>
+            <a:off x="1371600" y="1051560"/>
             <a:ext cx="2743200" cy="475488"/>
           </a:xfrm>
           <a:prstGeom prst="rect">
@@ -6542,7 +6407,7 @@
         </p:nvSpPr>
         <p:spPr>
           <a:xfrm>
-            <a:off x="4114800" y="1610024"/>
+            <a:off x="4114800" y="1051560"/>
             <a:ext cx="4297680" cy="475488"/>
           </a:xfrm>
           <a:prstGeom prst="rect">
@@ -6581,7 +6446,7 @@
         </p:nvSpPr>
         <p:spPr>
           <a:xfrm>
-            <a:off x="1188720" y="2085512"/>
+            <a:off x="1188720" y="1527048"/>
             <a:ext cx="457200" cy="182880"/>
           </a:xfrm>
           <a:prstGeom prst="rect">
@@ -6617,7 +6482,7 @@
         </p:nvSpPr>
         <p:spPr>
           <a:xfrm>
-            <a:off x="640080" y="2314112"/>
+            <a:off x="640080" y="1755648"/>
             <a:ext cx="411480" cy="384048"/>
           </a:xfrm>
           <a:prstGeom prst="rect">
@@ -6644,7 +6509,7 @@
         </p:nvSpPr>
         <p:spPr>
           <a:xfrm>
-            <a:off x="640080" y="2314112"/>
+            <a:off x="640080" y="1755648"/>
             <a:ext cx="411480" cy="384048"/>
           </a:xfrm>
           <a:prstGeom prst="rect">
@@ -6683,7 +6548,7 @@
         </p:nvSpPr>
         <p:spPr>
           <a:xfrm>
-            <a:off x="1188720" y="2268392"/>
+            <a:off x="1188720" y="1709928"/>
             <a:ext cx="7315200" cy="475488"/>
           </a:xfrm>
           <a:prstGeom prst="rect">
@@ -6710,7 +6575,7 @@
         </p:nvSpPr>
         <p:spPr>
           <a:xfrm>
-            <a:off x="1188720" y="2268392"/>
+            <a:off x="1188720" y="1709928"/>
             <a:ext cx="36576" cy="475488"/>
           </a:xfrm>
           <a:prstGeom prst="rect">
@@ -6737,7 +6602,7 @@
         </p:nvSpPr>
         <p:spPr>
           <a:xfrm>
-            <a:off x="1371600" y="2268392"/>
+            <a:off x="1371600" y="1709928"/>
             <a:ext cx="2743200" cy="475488"/>
           </a:xfrm>
           <a:prstGeom prst="rect">
@@ -6776,7 +6641,7 @@
         </p:nvSpPr>
         <p:spPr>
           <a:xfrm>
-            <a:off x="4114800" y="2268392"/>
+            <a:off x="4114800" y="1709928"/>
             <a:ext cx="4297680" cy="475488"/>
           </a:xfrm>
           <a:prstGeom prst="rect">
@@ -6815,7 +6680,7 @@
         </p:nvSpPr>
         <p:spPr>
           <a:xfrm>
-            <a:off x="1188720" y="2743880"/>
+            <a:off x="1188720" y="2185416"/>
             <a:ext cx="457200" cy="182880"/>
           </a:xfrm>
           <a:prstGeom prst="rect">
@@ -6851,7 +6716,7 @@
         </p:nvSpPr>
         <p:spPr>
           <a:xfrm>
-            <a:off x="640080" y="2972480"/>
+            <a:off x="640080" y="2414016"/>
             <a:ext cx="411480" cy="384048"/>
           </a:xfrm>
           <a:prstGeom prst="rect">
@@ -6878,7 +6743,7 @@
         </p:nvSpPr>
         <p:spPr>
           <a:xfrm>
-            <a:off x="640080" y="2972480"/>
+            <a:off x="640080" y="2414016"/>
             <a:ext cx="411480" cy="384048"/>
           </a:xfrm>
           <a:prstGeom prst="rect">
@@ -6917,7 +6782,7 @@
         </p:nvSpPr>
         <p:spPr>
           <a:xfrm>
-            <a:off x="1188720" y="2926760"/>
+            <a:off x="1188720" y="2368296"/>
             <a:ext cx="7315200" cy="475488"/>
           </a:xfrm>
           <a:prstGeom prst="rect">
@@ -6944,7 +6809,7 @@
         </p:nvSpPr>
         <p:spPr>
           <a:xfrm>
-            <a:off x="1188720" y="2926760"/>
+            <a:off x="1188720" y="2368296"/>
             <a:ext cx="36576" cy="475488"/>
           </a:xfrm>
           <a:prstGeom prst="rect">
@@ -6971,7 +6836,7 @@
         </p:nvSpPr>
         <p:spPr>
           <a:xfrm>
-            <a:off x="1371600" y="2926760"/>
+            <a:off x="1371600" y="2368296"/>
             <a:ext cx="2743200" cy="475488"/>
           </a:xfrm>
           <a:prstGeom prst="rect">
@@ -7010,7 +6875,7 @@
         </p:nvSpPr>
         <p:spPr>
           <a:xfrm>
-            <a:off x="4114800" y="2926760"/>
+            <a:off x="4114800" y="2368296"/>
             <a:ext cx="4297680" cy="475488"/>
           </a:xfrm>
           <a:prstGeom prst="rect">
@@ -7049,7 +6914,7 @@
         </p:nvSpPr>
         <p:spPr>
           <a:xfrm>
-            <a:off x="1188720" y="3402248"/>
+            <a:off x="1188720" y="2843784"/>
             <a:ext cx="457200" cy="182880"/>
           </a:xfrm>
           <a:prstGeom prst="rect">
@@ -7085,7 +6950,7 @@
         </p:nvSpPr>
         <p:spPr>
           <a:xfrm>
-            <a:off x="640080" y="3630848"/>
+            <a:off x="640080" y="3072384"/>
             <a:ext cx="411480" cy="384048"/>
           </a:xfrm>
           <a:prstGeom prst="rect">
@@ -7112,7 +6977,7 @@
         </p:nvSpPr>
         <p:spPr>
           <a:xfrm>
-            <a:off x="640080" y="3630848"/>
+            <a:off x="640080" y="3072384"/>
             <a:ext cx="411480" cy="384048"/>
           </a:xfrm>
           <a:prstGeom prst="rect">
@@ -7151,7 +7016,7 @@
         </p:nvSpPr>
         <p:spPr>
           <a:xfrm>
-            <a:off x="1188720" y="3585128"/>
+            <a:off x="1188720" y="3026664"/>
             <a:ext cx="7315200" cy="475488"/>
           </a:xfrm>
           <a:prstGeom prst="rect">
@@ -7178,7 +7043,7 @@
         </p:nvSpPr>
         <p:spPr>
           <a:xfrm>
-            <a:off x="1188720" y="3585128"/>
+            <a:off x="1188720" y="3026664"/>
             <a:ext cx="36576" cy="475488"/>
           </a:xfrm>
           <a:prstGeom prst="rect">
@@ -7205,7 +7070,7 @@
         </p:nvSpPr>
         <p:spPr>
           <a:xfrm>
-            <a:off x="1371600" y="3585128"/>
+            <a:off x="1371600" y="3026664"/>
             <a:ext cx="2743200" cy="475488"/>
           </a:xfrm>
           <a:prstGeom prst="rect">
@@ -7244,7 +7109,7 @@
         </p:nvSpPr>
         <p:spPr>
           <a:xfrm>
-            <a:off x="4114800" y="3585128"/>
+            <a:off x="4114800" y="3026664"/>
             <a:ext cx="4297680" cy="475488"/>
           </a:xfrm>
           <a:prstGeom prst="rect">
@@ -7448,7 +7313,7 @@
         </p:nvSpPr>
         <p:spPr>
           <a:xfrm>
-            <a:off x="640080" y="1444325"/>
+            <a:off x="640080" y="1051560"/>
             <a:ext cx="822960" cy="594360"/>
           </a:xfrm>
           <a:prstGeom prst="rect">
@@ -7475,7 +7340,7 @@
         </p:nvSpPr>
         <p:spPr>
           <a:xfrm>
-            <a:off x="640080" y="1444325"/>
+            <a:off x="640080" y="1051560"/>
             <a:ext cx="822960" cy="594360"/>
           </a:xfrm>
           <a:prstGeom prst="rect">
@@ -7514,7 +7379,7 @@
         </p:nvSpPr>
         <p:spPr>
           <a:xfrm>
-            <a:off x="1600200" y="1444325"/>
+            <a:off x="1600200" y="1051560"/>
             <a:ext cx="6903720" cy="594360"/>
           </a:xfrm>
           <a:prstGeom prst="rect">
@@ -7541,7 +7406,7 @@
         </p:nvSpPr>
         <p:spPr>
           <a:xfrm>
-            <a:off x="1783080" y="1444325"/>
+            <a:off x="1783080" y="1051560"/>
             <a:ext cx="2926080" cy="594360"/>
           </a:xfrm>
           <a:prstGeom prst="rect">
@@ -7580,7 +7445,7 @@
         </p:nvSpPr>
         <p:spPr>
           <a:xfrm>
-            <a:off x="4754880" y="1444325"/>
+            <a:off x="4754880" y="1051560"/>
             <a:ext cx="3657600" cy="594360"/>
           </a:xfrm>
           <a:prstGeom prst="rect">
@@ -7619,7 +7484,7 @@
         </p:nvSpPr>
         <p:spPr>
           <a:xfrm>
-            <a:off x="640080" y="2267285"/>
+            <a:off x="640080" y="1874520"/>
             <a:ext cx="822960" cy="594360"/>
           </a:xfrm>
           <a:prstGeom prst="rect">
@@ -7646,7 +7511,7 @@
         </p:nvSpPr>
         <p:spPr>
           <a:xfrm>
-            <a:off x="640080" y="2267285"/>
+            <a:off x="640080" y="1874520"/>
             <a:ext cx="822960" cy="594360"/>
           </a:xfrm>
           <a:prstGeom prst="rect">
@@ -7685,7 +7550,7 @@
         </p:nvSpPr>
         <p:spPr>
           <a:xfrm>
-            <a:off x="1600200" y="2267285"/>
+            <a:off x="1600200" y="1874520"/>
             <a:ext cx="6903720" cy="594360"/>
           </a:xfrm>
           <a:prstGeom prst="rect">
@@ -7712,7 +7577,7 @@
         </p:nvSpPr>
         <p:spPr>
           <a:xfrm>
-            <a:off x="1783080" y="2267285"/>
+            <a:off x="1783080" y="1874520"/>
             <a:ext cx="2926080" cy="594360"/>
           </a:xfrm>
           <a:prstGeom prst="rect">
@@ -7751,7 +7616,7 @@
         </p:nvSpPr>
         <p:spPr>
           <a:xfrm>
-            <a:off x="4754880" y="2267285"/>
+            <a:off x="4754880" y="1874520"/>
             <a:ext cx="3657600" cy="594360"/>
           </a:xfrm>
           <a:prstGeom prst="rect">
@@ -7790,7 +7655,7 @@
         </p:nvSpPr>
         <p:spPr>
           <a:xfrm>
-            <a:off x="640080" y="3090245"/>
+            <a:off x="640080" y="2697480"/>
             <a:ext cx="822960" cy="594360"/>
           </a:xfrm>
           <a:prstGeom prst="rect">
@@ -7817,7 +7682,7 @@
         </p:nvSpPr>
         <p:spPr>
           <a:xfrm>
-            <a:off x="640080" y="3090245"/>
+            <a:off x="640080" y="2697480"/>
             <a:ext cx="822960" cy="594360"/>
           </a:xfrm>
           <a:prstGeom prst="rect">
@@ -7856,7 +7721,7 @@
         </p:nvSpPr>
         <p:spPr>
           <a:xfrm>
-            <a:off x="1600200" y="3090245"/>
+            <a:off x="1600200" y="2697480"/>
             <a:ext cx="6903720" cy="594360"/>
           </a:xfrm>
           <a:prstGeom prst="rect">
@@ -7883,7 +7748,7 @@
         </p:nvSpPr>
         <p:spPr>
           <a:xfrm>
-            <a:off x="1783080" y="3090245"/>
+            <a:off x="1783080" y="2697480"/>
             <a:ext cx="2926080" cy="594360"/>
           </a:xfrm>
           <a:prstGeom prst="rect">
@@ -7922,7 +7787,7 @@
         </p:nvSpPr>
         <p:spPr>
           <a:xfrm>
-            <a:off x="4754880" y="3090245"/>
+            <a:off x="4754880" y="2697480"/>
             <a:ext cx="3657600" cy="594360"/>
           </a:xfrm>
           <a:prstGeom prst="rect">
@@ -8126,7 +7991,7 @@
         </p:nvSpPr>
         <p:spPr>
           <a:xfrm>
-            <a:off x="640080" y="1490045"/>
+            <a:off x="640080" y="1097280"/>
             <a:ext cx="7863840" cy="320040"/>
           </a:xfrm>
           <a:prstGeom prst="rect">
@@ -8168,8 +8033,8 @@
         </p:nvSpPr>
         <p:spPr>
           <a:xfrm>
-            <a:off x="640080" y="1444325"/>
-            <a:ext cx="8074336" cy="685800"/>
+            <a:off x="640080" y="1051560"/>
+            <a:ext cx="7863840" cy="685800"/>
           </a:xfrm>
           <a:prstGeom prst="rect">
             <a:avLst/>
@@ -8195,7 +8060,7 @@
         </p:nvSpPr>
         <p:spPr>
           <a:xfrm>
-            <a:off x="731520" y="1444325"/>
+            <a:off x="731520" y="1051560"/>
             <a:ext cx="411480" cy="685800"/>
           </a:xfrm>
           <a:prstGeom prst="rect">
@@ -8231,7 +8096,7 @@
         </p:nvSpPr>
         <p:spPr>
           <a:xfrm>
-            <a:off x="1234440" y="1444325"/>
+            <a:off x="1234440" y="1051560"/>
             <a:ext cx="1005840" cy="347472"/>
           </a:xfrm>
           <a:prstGeom prst="rect">
@@ -8270,7 +8135,7 @@
         </p:nvSpPr>
         <p:spPr>
           <a:xfrm>
-            <a:off x="1234440" y="1764365"/>
+            <a:off x="1234440" y="1371600"/>
             <a:ext cx="3200400" cy="320040"/>
           </a:xfrm>
           <a:prstGeom prst="rect">
@@ -8309,8 +8174,8 @@
         </p:nvSpPr>
         <p:spPr>
           <a:xfrm>
-            <a:off x="4197649" y="1444325"/>
-            <a:ext cx="4516768" cy="685800"/>
+            <a:off x="4572000" y="1051560"/>
+            <a:ext cx="3840480" cy="685800"/>
           </a:xfrm>
           <a:prstGeom prst="rect">
             <a:avLst/>
@@ -8351,8 +8216,8 @@
         </p:nvSpPr>
         <p:spPr>
           <a:xfrm>
-            <a:off x="640080" y="2267285"/>
-            <a:ext cx="8074336" cy="685800"/>
+            <a:off x="640080" y="1874520"/>
+            <a:ext cx="7863840" cy="685800"/>
           </a:xfrm>
           <a:prstGeom prst="rect">
             <a:avLst/>
@@ -8378,7 +8243,7 @@
         </p:nvSpPr>
         <p:spPr>
           <a:xfrm>
-            <a:off x="731520" y="2267285"/>
+            <a:off x="731520" y="1874520"/>
             <a:ext cx="411480" cy="685800"/>
           </a:xfrm>
           <a:prstGeom prst="rect">
@@ -8414,7 +8279,7 @@
         </p:nvSpPr>
         <p:spPr>
           <a:xfrm>
-            <a:off x="1234440" y="2267285"/>
+            <a:off x="1234440" y="1874520"/>
             <a:ext cx="1005840" cy="347472"/>
           </a:xfrm>
           <a:prstGeom prst="rect">
@@ -8453,7 +8318,7 @@
         </p:nvSpPr>
         <p:spPr>
           <a:xfrm>
-            <a:off x="1234440" y="2587325"/>
+            <a:off x="1234440" y="2194560"/>
             <a:ext cx="3200400" cy="320040"/>
           </a:xfrm>
           <a:prstGeom prst="rect">
@@ -8492,8 +8357,8 @@
         </p:nvSpPr>
         <p:spPr>
           <a:xfrm>
-            <a:off x="4197649" y="2267285"/>
-            <a:ext cx="4516768" cy="685800"/>
+            <a:off x="4572000" y="1874520"/>
+            <a:ext cx="3840480" cy="685800"/>
           </a:xfrm>
           <a:prstGeom prst="rect">
             <a:avLst/>
@@ -8534,8 +8399,8 @@
         </p:nvSpPr>
         <p:spPr>
           <a:xfrm>
-            <a:off x="640080" y="3090245"/>
-            <a:ext cx="8074336" cy="685800"/>
+            <a:off x="640080" y="2697480"/>
+            <a:ext cx="7863840" cy="685800"/>
           </a:xfrm>
           <a:prstGeom prst="rect">
             <a:avLst/>
@@ -8549,7 +8414,7 @@
           <a:bodyPr/>
           <a:lstStyle/>
           <a:p>
-            <a:endParaRPr lang="ko-KR" altLang="en-US" dirty="0"/>
+            <a:endParaRPr lang="ko-KR" altLang="en-US"/>
           </a:p>
         </p:txBody>
       </p:sp>
@@ -8561,7 +8426,7 @@
         </p:nvSpPr>
         <p:spPr>
           <a:xfrm>
-            <a:off x="731520" y="3090245"/>
+            <a:off x="731520" y="2697480"/>
             <a:ext cx="411480" cy="685800"/>
           </a:xfrm>
           <a:prstGeom prst="rect">
@@ -8597,8 +8462,8 @@
         </p:nvSpPr>
         <p:spPr>
           <a:xfrm>
-            <a:off x="1234440" y="3090245"/>
-            <a:ext cx="2300422" cy="347472"/>
+            <a:off x="1234440" y="2697480"/>
+            <a:ext cx="1005840" cy="347472"/>
           </a:xfrm>
           <a:prstGeom prst="rect">
             <a:avLst/>
@@ -8624,39 +8489,6 @@
               </a:rPr>
               <a:t>EM</a:t>
             </a:r>
-            <a:r>
-              <a:rPr lang="en-US" altLang="ko-KR" sz="1400" dirty="0">
-                <a:solidFill>
-                  <a:srgbClr val="111111"/>
-                </a:solidFill>
-                <a:latin typeface="NanumGothicExtraBold" pitchFamily="34" charset="0"/>
-                <a:ea typeface="NanumGothicExtraBold" pitchFamily="34" charset="-122"/>
-                <a:cs typeface="NanumGothicExtraBold" pitchFamily="34" charset="-120"/>
-              </a:rPr>
-              <a:t>(Engineering</a:t>
-            </a:r>
-            <a:r>
-              <a:rPr lang="ko-KR" altLang="en-US" sz="1400" dirty="0">
-                <a:solidFill>
-                  <a:srgbClr val="111111"/>
-                </a:solidFill>
-                <a:latin typeface="NanumGothicExtraBold" pitchFamily="34" charset="0"/>
-                <a:ea typeface="NanumGothicExtraBold" pitchFamily="34" charset="-122"/>
-                <a:cs typeface="NanumGothicExtraBold" pitchFamily="34" charset="-120"/>
-              </a:rPr>
-              <a:t> </a:t>
-            </a:r>
-            <a:r>
-              <a:rPr lang="en-US" altLang="ko-KR" sz="1400" dirty="0">
-                <a:solidFill>
-                  <a:srgbClr val="111111"/>
-                </a:solidFill>
-                <a:latin typeface="NanumGothicExtraBold" pitchFamily="34" charset="0"/>
-                <a:ea typeface="NanumGothicExtraBold" pitchFamily="34" charset="-122"/>
-                <a:cs typeface="NanumGothicExtraBold" pitchFamily="34" charset="-120"/>
-              </a:rPr>
-              <a:t>Manager)</a:t>
-            </a:r>
             <a:endParaRPr lang="en-US" sz="1400" dirty="0"/>
           </a:p>
         </p:txBody>
@@ -8669,7 +8501,7 @@
         </p:nvSpPr>
         <p:spPr>
           <a:xfrm>
-            <a:off x="1234440" y="3410285"/>
+            <a:off x="1234440" y="3017520"/>
             <a:ext cx="3200400" cy="320040"/>
           </a:xfrm>
           <a:prstGeom prst="rect">
@@ -8708,8 +8540,8 @@
         </p:nvSpPr>
         <p:spPr>
           <a:xfrm>
-            <a:off x="4197649" y="3090245"/>
-            <a:ext cx="4516768" cy="685800"/>
+            <a:off x="4572000" y="2697480"/>
+            <a:ext cx="3840480" cy="685800"/>
           </a:xfrm>
           <a:prstGeom prst="rect">
             <a:avLst/>
@@ -8736,72 +8568,7 @@
                 <a:ea typeface="NanumGothic" pitchFamily="34" charset="-122"/>
                 <a:cs typeface="NanumGothic" pitchFamily="34" charset="-120"/>
               </a:rPr>
-              <a:t>성공 지표 측정 가능성 · 비용 추정 · 공수 산정(MD/MM) · </a:t>
-            </a:r>
-            <a:r>
-              <a:rPr lang="en-US" sz="1000" dirty="0" err="1">
-                <a:solidFill>
-                  <a:srgbClr val="6B7280"/>
-                </a:solidFill>
-                <a:latin typeface="NanumGothic" pitchFamily="34" charset="0"/>
-                <a:ea typeface="NanumGothic" pitchFamily="34" charset="-122"/>
-                <a:cs typeface="NanumGothic" pitchFamily="34" charset="-120"/>
-              </a:rPr>
-              <a:t>스코프</a:t>
-            </a:r>
-            <a:r>
-              <a:rPr lang="en-US" sz="1000" dirty="0">
-                <a:solidFill>
-                  <a:srgbClr val="6B7280"/>
-                </a:solidFill>
-                <a:latin typeface="NanumGothic" pitchFamily="34" charset="0"/>
-                <a:ea typeface="NanumGothic" pitchFamily="34" charset="-122"/>
-                <a:cs typeface="NanumGothic" pitchFamily="34" charset="-120"/>
-              </a:rPr>
-              <a:t> </a:t>
-            </a:r>
-            <a:r>
-              <a:rPr lang="en-US" sz="1000" dirty="0" err="1">
-                <a:solidFill>
-                  <a:srgbClr val="6B7280"/>
-                </a:solidFill>
-                <a:latin typeface="NanumGothic" pitchFamily="34" charset="0"/>
-                <a:ea typeface="NanumGothic" pitchFamily="34" charset="-122"/>
-                <a:cs typeface="NanumGothic" pitchFamily="34" charset="-120"/>
-              </a:rPr>
-              <a:t>실현성</a:t>
-            </a:r>
-            <a:br>
-              <a:rPr lang="en-US" sz="1000" dirty="0">
-                <a:solidFill>
-                  <a:srgbClr val="6B7280"/>
-                </a:solidFill>
-                <a:latin typeface="NanumGothic" pitchFamily="34" charset="0"/>
-                <a:ea typeface="NanumGothic" pitchFamily="34" charset="-122"/>
-                <a:cs typeface="NanumGothic" pitchFamily="34" charset="-120"/>
-              </a:rPr>
-            </a:br>
-            <a:r>
-              <a:rPr lang="en-US" sz="1000" dirty="0">
-                <a:solidFill>
-                  <a:srgbClr val="6B7280"/>
-                </a:solidFill>
-                <a:latin typeface="NanumGothic" pitchFamily="34" charset="0"/>
-                <a:ea typeface="NanumGothic" pitchFamily="34" charset="-122"/>
-                <a:cs typeface="NanumGothic" pitchFamily="34" charset="-120"/>
-              </a:rPr>
-              <a:t> · NFR</a:t>
-            </a:r>
-            <a:r>
-              <a:rPr lang="en-US" altLang="ko-KR" sz="1000" dirty="0">
-                <a:solidFill>
-                  <a:srgbClr val="6B7280"/>
-                </a:solidFill>
-                <a:latin typeface="NanumGothic" pitchFamily="34" charset="0"/>
-                <a:ea typeface="NanumGothic" pitchFamily="34" charset="-122"/>
-                <a:cs typeface="NanumGothic" pitchFamily="34" charset="-120"/>
-              </a:rPr>
-              <a:t>(Non Functional Requirements: Scope Out)</a:t>
+              <a:t>성공 지표 측정 가능성 · 비용 추정 · 공수 산정(MD/MM) · 스코프 실현성 · NFR</a:t>
             </a:r>
             <a:endParaRPr lang="en-US" sz="1000" dirty="0"/>
           </a:p>
@@ -8981,14 +8748,14 @@
           <p:nvPr>
             <p:extLst>
               <p:ext uri="{D42A27DB-BD31-4B8C-83A1-F6EECF244321}">
-                <p14:modId xmlns:p14="http://schemas.microsoft.com/office/powerpoint/2010/main" val="3861972906"/>
+                <p14:modId xmlns:p14="http://schemas.microsoft.com/office/powerpoint/2010/main" val="1579011935"/>
               </p:ext>
             </p:extLst>
           </p:nvPr>
         </p:nvGraphicFramePr>
         <p:xfrm>
-          <a:off x="457200" y="1370683"/>
-          <a:ext cx="8229600" cy="2377440"/>
+          <a:off x="457200" y="1051560"/>
+          <a:ext cx="8229600" cy="914400"/>
         </p:xfrm>
         <a:graphic>
           <a:graphicData uri="http://schemas.openxmlformats.org/drawingml/2006/table">
@@ -10050,7 +9817,7 @@
                           <a:ea typeface="NanumGothic" pitchFamily="34" charset="-122"/>
                           <a:cs typeface="NanumGothic" pitchFamily="34" charset="-120"/>
                         </a:rPr>
-                        <a:t>Claude, Figma AI (Make), v0</a:t>
+                        <a:t>Figma AI (Make), v0</a:t>
                       </a:r>
                       <a:endParaRPr lang="en-US" sz="1200" dirty="0">
                         <a:latin typeface="NanumGothic" charset="0"/>
@@ -10317,7 +10084,7 @@
                           <a:ea typeface="NanumGothic" pitchFamily="34" charset="-122"/>
                           <a:cs typeface="NanumGothic" pitchFamily="34" charset="-120"/>
                         </a:rPr>
-                        <a:t>Claude, Cursor, Replit</a:t>
+                        <a:t>Claude Code, Cursor, Replit</a:t>
                       </a:r>
                       <a:endParaRPr lang="en-US" sz="1200" dirty="0">
                         <a:latin typeface="NanumGothic" charset="0"/>
@@ -10584,29 +10351,7 @@
                           <a:ea typeface="NanumGothic" pitchFamily="34" charset="-122"/>
                           <a:cs typeface="NanumGothic" pitchFamily="34" charset="-120"/>
                         </a:rPr>
-                        <a:t>Claude, </a:t>
-                      </a:r>
-                      <a:r>
-                        <a:rPr lang="en-US" sz="1200" dirty="0" err="1">
-                          <a:solidFill>
-                            <a:srgbClr val="000000"/>
-                          </a:solidFill>
-                          <a:latin typeface="NanumGothic" pitchFamily="34" charset="0"/>
-                          <a:ea typeface="NanumGothic" pitchFamily="34" charset="-122"/>
-                          <a:cs typeface="NanumGothic" pitchFamily="34" charset="-120"/>
-                        </a:rPr>
-                        <a:t>Vercel</a:t>
-                      </a:r>
-                      <a:r>
-                        <a:rPr lang="en-US" sz="1200" dirty="0">
-                          <a:solidFill>
-                            <a:srgbClr val="000000"/>
-                          </a:solidFill>
-                          <a:latin typeface="NanumGothic" pitchFamily="34" charset="0"/>
-                          <a:ea typeface="NanumGothic" pitchFamily="34" charset="-122"/>
-                          <a:cs typeface="NanumGothic" pitchFamily="34" charset="-120"/>
-                        </a:rPr>
-                        <a:t>, Replit, Lovable</a:t>
+                        <a:t>Vercel, Replit, Lovable</a:t>
                       </a:r>
                       <a:endParaRPr lang="en-US" sz="1200" dirty="0">
                         <a:latin typeface="NanumGothic" charset="0"/>
@@ -10837,7 +10582,7 @@
         </p:nvSpPr>
         <p:spPr>
           <a:xfrm>
-            <a:off x="640080" y="1071349"/>
+            <a:off x="640080" y="1097280"/>
             <a:ext cx="7863840" cy="320040"/>
           </a:xfrm>
           <a:prstGeom prst="rect">
@@ -10879,7 +10624,7 @@
         </p:nvSpPr>
         <p:spPr>
           <a:xfrm>
-            <a:off x="640080" y="1502687"/>
+            <a:off x="640080" y="1042416"/>
             <a:ext cx="347472" cy="347472"/>
           </a:xfrm>
           <a:prstGeom prst="ellipse">
@@ -10906,7 +10651,7 @@
         </p:nvSpPr>
         <p:spPr>
           <a:xfrm>
-            <a:off x="640080" y="1502687"/>
+            <a:off x="640080" y="1042416"/>
             <a:ext cx="347472" cy="347472"/>
           </a:xfrm>
           <a:prstGeom prst="rect">
@@ -10945,7 +10690,7 @@
         </p:nvSpPr>
         <p:spPr>
           <a:xfrm>
-            <a:off x="1188720" y="1466111"/>
+            <a:off x="1188720" y="1005840"/>
             <a:ext cx="1554480" cy="411480"/>
           </a:xfrm>
           <a:prstGeom prst="rect">
@@ -10984,7 +10729,7 @@
         </p:nvSpPr>
         <p:spPr>
           <a:xfrm>
-            <a:off x="2834640" y="1466111"/>
+            <a:off x="2834640" y="1005840"/>
             <a:ext cx="2926080" cy="411480"/>
           </a:xfrm>
           <a:prstGeom prst="rect">
@@ -11023,7 +10768,7 @@
         </p:nvSpPr>
         <p:spPr>
           <a:xfrm>
-            <a:off x="5852160" y="1466111"/>
+            <a:off x="5852160" y="1005840"/>
             <a:ext cx="2651760" cy="411480"/>
           </a:xfrm>
           <a:prstGeom prst="rect">
@@ -11062,7 +10807,7 @@
         </p:nvSpPr>
         <p:spPr>
           <a:xfrm>
-            <a:off x="640080" y="1978175"/>
+            <a:off x="640080" y="1517904"/>
             <a:ext cx="347472" cy="347472"/>
           </a:xfrm>
           <a:prstGeom prst="ellipse">
@@ -11089,7 +10834,7 @@
         </p:nvSpPr>
         <p:spPr>
           <a:xfrm>
-            <a:off x="640080" y="1978175"/>
+            <a:off x="640080" y="1517904"/>
             <a:ext cx="347472" cy="347472"/>
           </a:xfrm>
           <a:prstGeom prst="rect">
@@ -11128,7 +10873,7 @@
         </p:nvSpPr>
         <p:spPr>
           <a:xfrm>
-            <a:off x="1188720" y="1941599"/>
+            <a:off x="1188720" y="1481328"/>
             <a:ext cx="1554480" cy="411480"/>
           </a:xfrm>
           <a:prstGeom prst="rect">
@@ -11167,7 +10912,7 @@
         </p:nvSpPr>
         <p:spPr>
           <a:xfrm>
-            <a:off x="2834640" y="1941599"/>
+            <a:off x="2834640" y="1481328"/>
             <a:ext cx="2926080" cy="411480"/>
           </a:xfrm>
           <a:prstGeom prst="rect">
@@ -11206,7 +10951,7 @@
         </p:nvSpPr>
         <p:spPr>
           <a:xfrm>
-            <a:off x="5852160" y="1941599"/>
+            <a:off x="5852160" y="1481328"/>
             <a:ext cx="2651760" cy="411480"/>
           </a:xfrm>
           <a:prstGeom prst="rect">
@@ -11245,7 +10990,7 @@
         </p:nvSpPr>
         <p:spPr>
           <a:xfrm>
-            <a:off x="640080" y="2453663"/>
+            <a:off x="640080" y="1993392"/>
             <a:ext cx="347472" cy="347472"/>
           </a:xfrm>
           <a:prstGeom prst="ellipse">
@@ -11272,7 +11017,7 @@
         </p:nvSpPr>
         <p:spPr>
           <a:xfrm>
-            <a:off x="640080" y="2453663"/>
+            <a:off x="640080" y="1993392"/>
             <a:ext cx="347472" cy="347472"/>
           </a:xfrm>
           <a:prstGeom prst="rect">
@@ -11311,7 +11056,7 @@
         </p:nvSpPr>
         <p:spPr>
           <a:xfrm>
-            <a:off x="1188720" y="2417087"/>
+            <a:off x="1188720" y="1956816"/>
             <a:ext cx="1554480" cy="411480"/>
           </a:xfrm>
           <a:prstGeom prst="rect">
@@ -11350,7 +11095,7 @@
         </p:nvSpPr>
         <p:spPr>
           <a:xfrm>
-            <a:off x="2834640" y="2417087"/>
+            <a:off x="2834640" y="1956816"/>
             <a:ext cx="2926080" cy="411480"/>
           </a:xfrm>
           <a:prstGeom prst="rect">
@@ -11389,7 +11134,7 @@
         </p:nvSpPr>
         <p:spPr>
           <a:xfrm>
-            <a:off x="5852160" y="2417087"/>
+            <a:off x="5852160" y="1956816"/>
             <a:ext cx="2651760" cy="411480"/>
           </a:xfrm>
           <a:prstGeom prst="rect">
@@ -11428,7 +11173,7 @@
         </p:nvSpPr>
         <p:spPr>
           <a:xfrm>
-            <a:off x="640080" y="2929151"/>
+            <a:off x="640080" y="2468880"/>
             <a:ext cx="347472" cy="347472"/>
           </a:xfrm>
           <a:prstGeom prst="ellipse">
@@ -11455,7 +11200,7 @@
         </p:nvSpPr>
         <p:spPr>
           <a:xfrm>
-            <a:off x="640080" y="2929151"/>
+            <a:off x="640080" y="2468880"/>
             <a:ext cx="347472" cy="347472"/>
           </a:xfrm>
           <a:prstGeom prst="rect">
@@ -11494,7 +11239,7 @@
         </p:nvSpPr>
         <p:spPr>
           <a:xfrm>
-            <a:off x="1188720" y="2892575"/>
+            <a:off x="1188720" y="2432304"/>
             <a:ext cx="1554480" cy="411480"/>
           </a:xfrm>
           <a:prstGeom prst="rect">
@@ -11533,7 +11278,7 @@
         </p:nvSpPr>
         <p:spPr>
           <a:xfrm>
-            <a:off x="2834640" y="2892575"/>
+            <a:off x="2834640" y="2432304"/>
             <a:ext cx="2926080" cy="411480"/>
           </a:xfrm>
           <a:prstGeom prst="rect">
@@ -11572,7 +11317,7 @@
         </p:nvSpPr>
         <p:spPr>
           <a:xfrm>
-            <a:off x="5852160" y="2892575"/>
+            <a:off x="5852160" y="2432304"/>
             <a:ext cx="2651760" cy="411480"/>
           </a:xfrm>
           <a:prstGeom prst="rect">
@@ -11611,7 +11356,7 @@
         </p:nvSpPr>
         <p:spPr>
           <a:xfrm>
-            <a:off x="640080" y="3404639"/>
+            <a:off x="640080" y="2944368"/>
             <a:ext cx="347472" cy="347472"/>
           </a:xfrm>
           <a:prstGeom prst="ellipse">
@@ -11638,7 +11383,7 @@
         </p:nvSpPr>
         <p:spPr>
           <a:xfrm>
-            <a:off x="640080" y="3404639"/>
+            <a:off x="640080" y="2944368"/>
             <a:ext cx="347472" cy="347472"/>
           </a:xfrm>
           <a:prstGeom prst="rect">
@@ -11677,7 +11422,7 @@
         </p:nvSpPr>
         <p:spPr>
           <a:xfrm>
-            <a:off x="1188720" y="3368063"/>
+            <a:off x="1188720" y="2907792"/>
             <a:ext cx="1554480" cy="411480"/>
           </a:xfrm>
           <a:prstGeom prst="rect">
@@ -11716,7 +11461,7 @@
         </p:nvSpPr>
         <p:spPr>
           <a:xfrm>
-            <a:off x="2834640" y="3368063"/>
+            <a:off x="2834640" y="2907792"/>
             <a:ext cx="2926080" cy="411480"/>
           </a:xfrm>
           <a:prstGeom prst="rect">
@@ -11755,7 +11500,7 @@
         </p:nvSpPr>
         <p:spPr>
           <a:xfrm>
-            <a:off x="5852160" y="3368063"/>
+            <a:off x="5852160" y="2907792"/>
             <a:ext cx="2651760" cy="411480"/>
           </a:xfrm>
           <a:prstGeom prst="rect">
@@ -11794,7 +11539,7 @@
         </p:nvSpPr>
         <p:spPr>
           <a:xfrm>
-            <a:off x="640080" y="3934991"/>
+            <a:off x="640080" y="3474720"/>
             <a:ext cx="7863840" cy="411480"/>
           </a:xfrm>
           <a:prstGeom prst="rect">
@@ -11821,7 +11566,7 @@
         </p:nvSpPr>
         <p:spPr>
           <a:xfrm>
-            <a:off x="640080" y="3934991"/>
+            <a:off x="640080" y="3474720"/>
             <a:ext cx="7863840" cy="411480"/>
           </a:xfrm>
           <a:prstGeom prst="rect">
@@ -11986,7 +11731,7 @@
         </p:nvSpPr>
         <p:spPr>
           <a:xfrm>
-            <a:off x="640080" y="1533003"/>
+            <a:off x="640080" y="1097280"/>
             <a:ext cx="7863840" cy="320040"/>
           </a:xfrm>
           <a:prstGeom prst="rect">
@@ -12028,7 +11773,7 @@
         </p:nvSpPr>
         <p:spPr>
           <a:xfrm>
-            <a:off x="640080" y="1487283"/>
+            <a:off x="640080" y="1051560"/>
             <a:ext cx="7863840" cy="384048"/>
           </a:xfrm>
           <a:prstGeom prst="rect">
@@ -12055,7 +11800,7 @@
         </p:nvSpPr>
         <p:spPr>
           <a:xfrm>
-            <a:off x="777240" y="1487283"/>
+            <a:off x="777240" y="1051560"/>
             <a:ext cx="1920240" cy="384048"/>
           </a:xfrm>
           <a:prstGeom prst="rect">
@@ -12094,7 +11839,7 @@
         </p:nvSpPr>
         <p:spPr>
           <a:xfrm>
-            <a:off x="2743200" y="1487283"/>
+            <a:off x="2743200" y="1051560"/>
             <a:ext cx="2743200" cy="384048"/>
           </a:xfrm>
           <a:prstGeom prst="rect">
@@ -12133,7 +11878,7 @@
         </p:nvSpPr>
         <p:spPr>
           <a:xfrm>
-            <a:off x="5577840" y="1487283"/>
+            <a:off x="5577840" y="1051560"/>
             <a:ext cx="2834640" cy="384048"/>
           </a:xfrm>
           <a:prstGeom prst="rect">
@@ -12172,7 +11917,7 @@
         </p:nvSpPr>
         <p:spPr>
           <a:xfrm>
-            <a:off x="640080" y="1962771"/>
+            <a:off x="640080" y="1527048"/>
             <a:ext cx="7863840" cy="384048"/>
           </a:xfrm>
           <a:prstGeom prst="rect">
@@ -12199,7 +11944,7 @@
         </p:nvSpPr>
         <p:spPr>
           <a:xfrm>
-            <a:off x="777240" y="1962771"/>
+            <a:off x="777240" y="1527048"/>
             <a:ext cx="1920240" cy="384048"/>
           </a:xfrm>
           <a:prstGeom prst="rect">
@@ -12238,7 +11983,7 @@
         </p:nvSpPr>
         <p:spPr>
           <a:xfrm>
-            <a:off x="2743200" y="1962771"/>
+            <a:off x="2743200" y="1527048"/>
             <a:ext cx="2743200" cy="384048"/>
           </a:xfrm>
           <a:prstGeom prst="rect">
@@ -12277,7 +12022,7 @@
         </p:nvSpPr>
         <p:spPr>
           <a:xfrm>
-            <a:off x="5577840" y="1962771"/>
+            <a:off x="5577840" y="1527048"/>
             <a:ext cx="2834640" cy="384048"/>
           </a:xfrm>
           <a:prstGeom prst="rect">
@@ -12316,7 +12061,7 @@
         </p:nvSpPr>
         <p:spPr>
           <a:xfrm>
-            <a:off x="640080" y="2438259"/>
+            <a:off x="640080" y="2002536"/>
             <a:ext cx="7863840" cy="384048"/>
           </a:xfrm>
           <a:prstGeom prst="rect">
@@ -12343,7 +12088,7 @@
         </p:nvSpPr>
         <p:spPr>
           <a:xfrm>
-            <a:off x="777240" y="2438259"/>
+            <a:off x="777240" y="2002536"/>
             <a:ext cx="1920240" cy="384048"/>
           </a:xfrm>
           <a:prstGeom prst="rect">
@@ -12382,7 +12127,7 @@
         </p:nvSpPr>
         <p:spPr>
           <a:xfrm>
-            <a:off x="2743200" y="2438259"/>
+            <a:off x="2743200" y="2002536"/>
             <a:ext cx="2743200" cy="384048"/>
           </a:xfrm>
           <a:prstGeom prst="rect">
@@ -12421,7 +12166,7 @@
         </p:nvSpPr>
         <p:spPr>
           <a:xfrm>
-            <a:off x="5577840" y="2438259"/>
+            <a:off x="5577840" y="2002536"/>
             <a:ext cx="2834640" cy="384048"/>
           </a:xfrm>
           <a:prstGeom prst="rect">
@@ -12460,7 +12205,7 @@
         </p:nvSpPr>
         <p:spPr>
           <a:xfrm>
-            <a:off x="640080" y="2913747"/>
+            <a:off x="640080" y="2478024"/>
             <a:ext cx="7863840" cy="384048"/>
           </a:xfrm>
           <a:prstGeom prst="rect">
@@ -12487,7 +12232,7 @@
         </p:nvSpPr>
         <p:spPr>
           <a:xfrm>
-            <a:off x="777240" y="2913747"/>
+            <a:off x="777240" y="2478024"/>
             <a:ext cx="1920240" cy="384048"/>
           </a:xfrm>
           <a:prstGeom prst="rect">
@@ -12526,7 +12271,7 @@
         </p:nvSpPr>
         <p:spPr>
           <a:xfrm>
-            <a:off x="2743200" y="2913747"/>
+            <a:off x="2743200" y="2478024"/>
             <a:ext cx="2743200" cy="384048"/>
           </a:xfrm>
           <a:prstGeom prst="rect">
@@ -12565,7 +12310,7 @@
         </p:nvSpPr>
         <p:spPr>
           <a:xfrm>
-            <a:off x="5577840" y="2913747"/>
+            <a:off x="5577840" y="2478024"/>
             <a:ext cx="2834640" cy="384048"/>
           </a:xfrm>
           <a:prstGeom prst="rect">
@@ -12604,7 +12349,7 @@
         </p:nvSpPr>
         <p:spPr>
           <a:xfrm>
-            <a:off x="640080" y="3389235"/>
+            <a:off x="640080" y="2953512"/>
             <a:ext cx="7863840" cy="384048"/>
           </a:xfrm>
           <a:prstGeom prst="rect">
@@ -12631,7 +12376,7 @@
         </p:nvSpPr>
         <p:spPr>
           <a:xfrm>
-            <a:off x="777240" y="3389235"/>
+            <a:off x="777240" y="2953512"/>
             <a:ext cx="1920240" cy="384048"/>
           </a:xfrm>
           <a:prstGeom prst="rect">
@@ -12670,7 +12415,7 @@
         </p:nvSpPr>
         <p:spPr>
           <a:xfrm>
-            <a:off x="2743200" y="3389235"/>
+            <a:off x="2743200" y="2953512"/>
             <a:ext cx="2743200" cy="384048"/>
           </a:xfrm>
           <a:prstGeom prst="rect">
@@ -12709,7 +12454,7 @@
         </p:nvSpPr>
         <p:spPr>
           <a:xfrm>
-            <a:off x="5577840" y="3389235"/>
+            <a:off x="5577840" y="2953512"/>
             <a:ext cx="2834640" cy="384048"/>
           </a:xfrm>
           <a:prstGeom prst="rect">
@@ -12913,7 +12658,7 @@
         </p:nvSpPr>
         <p:spPr>
           <a:xfrm>
-            <a:off x="640080" y="1303177"/>
+            <a:off x="640080" y="1051560"/>
             <a:ext cx="7863840" cy="1097280"/>
           </a:xfrm>
           <a:prstGeom prst="rect">
@@ -12940,7 +12685,7 @@
         </p:nvSpPr>
         <p:spPr>
           <a:xfrm>
-            <a:off x="777240" y="1348897"/>
+            <a:off x="777240" y="1097280"/>
             <a:ext cx="7315200" cy="320040"/>
           </a:xfrm>
           <a:prstGeom prst="rect">
@@ -12965,29 +12710,151 @@
                 <a:ea typeface="NanumGothicExtraBold" pitchFamily="34" charset="-122"/>
                 <a:cs typeface="NanumGothicExtraBold" pitchFamily="34" charset="-120"/>
               </a:rPr>
-              <a:t>Workflow A:  기획 → </a:t>
-            </a:r>
-            <a:r>
-              <a:rPr lang="en-US" sz="1300" dirty="0" err="1">
-                <a:solidFill>
-                  <a:srgbClr val="FF6B35"/>
+              <a:t>Workflow A:  기획 → 프로토타입 → 배포 (오늘 실습)</a:t>
+            </a:r>
+            <a:endParaRPr lang="en-US" sz="1300" dirty="0"/>
+          </a:p>
+        </p:txBody>
+      </p:sp>
+      <p:sp>
+        <p:nvSpPr>
+          <p:cNvPr id="7" name="Text 5"/>
+          <p:cNvSpPr/>
+          <p:nvPr/>
+        </p:nvSpPr>
+        <p:spPr>
+          <a:xfrm>
+            <a:off x="777240" y="1463040"/>
+            <a:ext cx="7315200" cy="274320"/>
+          </a:xfrm>
+          <a:prstGeom prst="rect">
+            <a:avLst/>
+          </a:prstGeom>
+          <a:noFill/>
+          <a:ln/>
+        </p:spPr>
+        <p:txBody>
+          <a:bodyPr wrap="square" lIns="0" tIns="0" rIns="0" bIns="0" rtlCol="0" anchor="ctr"/>
+          <a:lstStyle/>
+          <a:p>
+            <a:pPr marL="0" indent="0">
+              <a:buNone/>
+            </a:pPr>
+            <a:r>
+              <a:rPr lang="en-US" sz="1200" dirty="0">
+                <a:solidFill>
+                  <a:srgbClr val="111111"/>
+                </a:solidFill>
+                <a:latin typeface="NanumGothic" pitchFamily="34" charset="0"/>
+                <a:ea typeface="NanumGothic" pitchFamily="34" charset="-122"/>
+                <a:cs typeface="NanumGothic" pitchFamily="34" charset="-120"/>
+              </a:rPr>
+              <a:t>Claude (리서치)  →  Manyfast (PRD)  →  Claude Code (프로토타입)  →  Vercel / Replit (배포)</a:t>
+            </a:r>
+            <a:endParaRPr lang="en-US" sz="1200" dirty="0"/>
+          </a:p>
+        </p:txBody>
+      </p:sp>
+      <p:sp>
+        <p:nvSpPr>
+          <p:cNvPr id="8" name="Text 6"/>
+          <p:cNvSpPr/>
+          <p:nvPr/>
+        </p:nvSpPr>
+        <p:spPr>
+          <a:xfrm>
+            <a:off x="777240" y="1783080"/>
+            <a:ext cx="7315200" cy="274320"/>
+          </a:xfrm>
+          <a:prstGeom prst="rect">
+            <a:avLst/>
+          </a:prstGeom>
+          <a:noFill/>
+          <a:ln/>
+        </p:spPr>
+        <p:txBody>
+          <a:bodyPr wrap="square" lIns="0" tIns="0" rIns="0" bIns="0" rtlCol="0" anchor="ctr"/>
+          <a:lstStyle/>
+          <a:p>
+            <a:pPr marL="0" indent="0">
+              <a:buNone/>
+            </a:pPr>
+            <a:r>
+              <a:rPr lang="en-US" sz="1000" dirty="0">
+                <a:solidFill>
+                  <a:srgbClr val="6B7280"/>
+                </a:solidFill>
+                <a:latin typeface="NanumGothic" pitchFamily="34" charset="0"/>
+                <a:ea typeface="NanumGothic" pitchFamily="34" charset="-122"/>
+                <a:cs typeface="NanumGothic" pitchFamily="34" charset="-120"/>
+              </a:rPr>
+              <a:t>5개 입력 → PRD 초안(~5분) → HTML 생성(~15분) → 배포(~2분)  =  총 30분 이내</a:t>
+            </a:r>
+            <a:endParaRPr lang="en-US" sz="1000" dirty="0"/>
+          </a:p>
+        </p:txBody>
+      </p:sp>
+      <p:sp>
+        <p:nvSpPr>
+          <p:cNvPr id="9" name="Shape 7"/>
+          <p:cNvSpPr/>
+          <p:nvPr/>
+        </p:nvSpPr>
+        <p:spPr>
+          <a:xfrm>
+            <a:off x="640080" y="2331720"/>
+            <a:ext cx="7863840" cy="1097280"/>
+          </a:xfrm>
+          <a:prstGeom prst="rect">
+            <a:avLst/>
+          </a:prstGeom>
+          <a:solidFill>
+            <a:srgbClr val="F5F5F5"/>
+          </a:solidFill>
+          <a:ln/>
+        </p:spPr>
+        <p:txBody>
+          <a:bodyPr/>
+          <a:lstStyle/>
+          <a:p>
+            <a:endParaRPr lang="ko-KR" altLang="en-US"/>
+          </a:p>
+        </p:txBody>
+      </p:sp>
+      <p:sp>
+        <p:nvSpPr>
+          <p:cNvPr id="10" name="Text 8"/>
+          <p:cNvSpPr/>
+          <p:nvPr/>
+        </p:nvSpPr>
+        <p:spPr>
+          <a:xfrm>
+            <a:off x="777240" y="2377440"/>
+            <a:ext cx="7315200" cy="320040"/>
+          </a:xfrm>
+          <a:prstGeom prst="rect">
+            <a:avLst/>
+          </a:prstGeom>
+          <a:noFill/>
+          <a:ln/>
+        </p:spPr>
+        <p:txBody>
+          <a:bodyPr wrap="square" lIns="0" tIns="0" rIns="0" bIns="0" rtlCol="0" anchor="ctr"/>
+          <a:lstStyle/>
+          <a:p>
+            <a:pPr marL="0" indent="0">
+              <a:buNone/>
+            </a:pPr>
+            <a:r>
+              <a:rPr lang="en-US" sz="1300" dirty="0">
+                <a:solidFill>
+                  <a:srgbClr val="111111"/>
                 </a:solidFill>
                 <a:latin typeface="NanumGothicExtraBold" pitchFamily="34" charset="0"/>
                 <a:ea typeface="NanumGothicExtraBold" pitchFamily="34" charset="-122"/>
                 <a:cs typeface="NanumGothicExtraBold" pitchFamily="34" charset="-120"/>
               </a:rPr>
-              <a:t>프로토타입</a:t>
-            </a:r>
-            <a:r>
-              <a:rPr lang="en-US" sz="1300" dirty="0">
-                <a:solidFill>
-                  <a:srgbClr val="FF6B35"/>
-                </a:solidFill>
-                <a:latin typeface="NanumGothicExtraBold" pitchFamily="34" charset="0"/>
-                <a:ea typeface="NanumGothicExtraBold" pitchFamily="34" charset="-122"/>
-                <a:cs typeface="NanumGothicExtraBold" pitchFamily="34" charset="-120"/>
-              </a:rPr>
-              <a:t> (오늘 실습)</a:t>
+              <a:t>Workflow B:  디자인 중심 (Figma 활용)</a:t>
             </a:r>
             <a:endParaRPr lang="en-US" sz="1300" dirty="0"/>
           </a:p>
@@ -12995,13 +12862,13 @@
       </p:sp>
       <p:sp>
         <p:nvSpPr>
-          <p:cNvPr id="7" name="Text 5"/>
-          <p:cNvSpPr/>
-          <p:nvPr/>
-        </p:nvSpPr>
-        <p:spPr>
-          <a:xfrm>
-            <a:off x="777240" y="1714657"/>
+          <p:cNvPr id="11" name="Text 9"/>
+          <p:cNvSpPr/>
+          <p:nvPr/>
+        </p:nvSpPr>
+        <p:spPr>
+          <a:xfrm>
+            <a:off x="777240" y="2743200"/>
             <a:ext cx="7315200" cy="274320"/>
           </a:xfrm>
           <a:prstGeom prst="rect">
@@ -13026,234 +12893,85 @@
                 <a:ea typeface="NanumGothic" pitchFamily="34" charset="-122"/>
                 <a:cs typeface="NanumGothic" pitchFamily="34" charset="-120"/>
               </a:rPr>
-              <a:t>Claude (리서치)  →  Manyfast (PRD)  →  Claude Code (</a:t>
-            </a:r>
-            <a:r>
-              <a:rPr lang="en-US" sz="1200" dirty="0" err="1">
-                <a:solidFill>
-                  <a:srgbClr val="111111"/>
+              <a:t>Claude (PRD)  →  Figma AI / Make (와이어프레임)  →  Google Stitch (코드 변환)  →  Lovable (배포)</a:t>
+            </a:r>
+            <a:endParaRPr lang="en-US" sz="1200" dirty="0"/>
+          </a:p>
+        </p:txBody>
+      </p:sp>
+      <p:sp>
+        <p:nvSpPr>
+          <p:cNvPr id="12" name="Text 10"/>
+          <p:cNvSpPr/>
+          <p:nvPr/>
+        </p:nvSpPr>
+        <p:spPr>
+          <a:xfrm>
+            <a:off x="777240" y="3063240"/>
+            <a:ext cx="7315200" cy="274320"/>
+          </a:xfrm>
+          <a:prstGeom prst="rect">
+            <a:avLst/>
+          </a:prstGeom>
+          <a:noFill/>
+          <a:ln/>
+        </p:spPr>
+        <p:txBody>
+          <a:bodyPr wrap="square" lIns="0" tIns="0" rIns="0" bIns="0" rtlCol="0" anchor="ctr"/>
+          <a:lstStyle/>
+          <a:p>
+            <a:pPr marL="0" indent="0">
+              <a:buNone/>
+            </a:pPr>
+            <a:r>
+              <a:rPr lang="en-US" sz="1000" dirty="0">
+                <a:solidFill>
+                  <a:srgbClr val="6B7280"/>
                 </a:solidFill>
                 <a:latin typeface="NanumGothic" pitchFamily="34" charset="0"/>
                 <a:ea typeface="NanumGothic" pitchFamily="34" charset="-122"/>
                 <a:cs typeface="NanumGothic" pitchFamily="34" charset="-120"/>
               </a:rPr>
-              <a:t>프로토타입</a:t>
-            </a:r>
-            <a:r>
-              <a:rPr lang="en-US" sz="1200" dirty="0">
-                <a:solidFill>
-                  <a:srgbClr val="111111"/>
+              <a:t>디자인 시스템이 중요한 B2C 서비스에 적합  |  Figma → 코드 자동 변환으로 개발 공수 절감</a:t>
+            </a:r>
+            <a:endParaRPr lang="en-US" sz="1000" dirty="0"/>
+          </a:p>
+        </p:txBody>
+      </p:sp>
+      <p:sp>
+        <p:nvSpPr>
+          <p:cNvPr id="13" name="Text 11"/>
+          <p:cNvSpPr/>
+          <p:nvPr/>
+        </p:nvSpPr>
+        <p:spPr>
+          <a:xfrm>
+            <a:off x="640080" y="4320540"/>
+            <a:ext cx="7863840" cy="274320"/>
+          </a:xfrm>
+          <a:prstGeom prst="rect">
+            <a:avLst/>
+          </a:prstGeom>
+          <a:noFill/>
+          <a:ln/>
+        </p:spPr>
+        <p:txBody>
+          <a:bodyPr wrap="square" lIns="0" tIns="0" rIns="0" bIns="0" rtlCol="0" anchor="ctr"/>
+          <a:lstStyle/>
+          <a:p>
+            <a:pPr marL="0" indent="0" algn="l">
+              <a:buNone/>
+            </a:pPr>
+            <a:r>
+              <a:rPr lang="en-US" sz="1000" i="1" dirty="0">
+                <a:solidFill>
+                  <a:srgbClr val="6B7280"/>
                 </a:solidFill>
                 <a:latin typeface="NanumGothic" pitchFamily="34" charset="0"/>
                 <a:ea typeface="NanumGothic" pitchFamily="34" charset="-122"/>
                 <a:cs typeface="NanumGothic" pitchFamily="34" charset="-120"/>
               </a:rPr>
-              <a:t>)</a:t>
-            </a:r>
-            <a:endParaRPr lang="en-US" sz="1200" dirty="0"/>
-          </a:p>
-        </p:txBody>
-      </p:sp>
-      <p:sp>
-        <p:nvSpPr>
-          <p:cNvPr id="8" name="Text 6"/>
-          <p:cNvSpPr/>
-          <p:nvPr/>
-        </p:nvSpPr>
-        <p:spPr>
-          <a:xfrm>
-            <a:off x="777240" y="2034697"/>
-            <a:ext cx="7315200" cy="274320"/>
-          </a:xfrm>
-          <a:prstGeom prst="rect">
-            <a:avLst/>
-          </a:prstGeom>
-          <a:noFill/>
-          <a:ln/>
-        </p:spPr>
-        <p:txBody>
-          <a:bodyPr wrap="square" lIns="0" tIns="0" rIns="0" bIns="0" rtlCol="0" anchor="ctr"/>
-          <a:lstStyle/>
-          <a:p>
-            <a:pPr marL="0" indent="0">
-              <a:buNone/>
-            </a:pPr>
-            <a:r>
-              <a:rPr lang="en-US" sz="1000" dirty="0">
-                <a:solidFill>
-                  <a:srgbClr val="6B7280"/>
-                </a:solidFill>
-                <a:latin typeface="NanumGothic" pitchFamily="34" charset="0"/>
-                <a:ea typeface="NanumGothic" pitchFamily="34" charset="-122"/>
-                <a:cs typeface="NanumGothic" pitchFamily="34" charset="-120"/>
-              </a:rPr>
-              <a:t>5개 입력 → PRD 초안(~5분) → HTML 생성(~15분) =  </a:t>
-            </a:r>
-            <a:r>
-              <a:rPr lang="en-US" sz="1000" dirty="0" err="1">
-                <a:solidFill>
-                  <a:srgbClr val="6B7280"/>
-                </a:solidFill>
-                <a:latin typeface="NanumGothic" pitchFamily="34" charset="0"/>
-                <a:ea typeface="NanumGothic" pitchFamily="34" charset="-122"/>
-                <a:cs typeface="NanumGothic" pitchFamily="34" charset="-120"/>
-              </a:rPr>
-              <a:t>총</a:t>
-            </a:r>
-            <a:r>
-              <a:rPr lang="en-US" sz="1000" dirty="0">
-                <a:solidFill>
-                  <a:srgbClr val="6B7280"/>
-                </a:solidFill>
-                <a:latin typeface="NanumGothic" pitchFamily="34" charset="0"/>
-                <a:ea typeface="NanumGothic" pitchFamily="34" charset="-122"/>
-                <a:cs typeface="NanumGothic" pitchFamily="34" charset="-120"/>
-              </a:rPr>
-              <a:t> 20분 이내</a:t>
-            </a:r>
-            <a:endParaRPr lang="en-US" sz="1000" dirty="0"/>
-          </a:p>
-        </p:txBody>
-      </p:sp>
-      <p:sp>
-        <p:nvSpPr>
-          <p:cNvPr id="9" name="Shape 7"/>
-          <p:cNvSpPr/>
-          <p:nvPr/>
-        </p:nvSpPr>
-        <p:spPr>
-          <a:xfrm>
-            <a:off x="640080" y="2583337"/>
-            <a:ext cx="7863840" cy="1097280"/>
-          </a:xfrm>
-          <a:prstGeom prst="rect">
-            <a:avLst/>
-          </a:prstGeom>
-          <a:solidFill>
-            <a:srgbClr val="F5F5F5"/>
-          </a:solidFill>
-          <a:ln/>
-        </p:spPr>
-        <p:txBody>
-          <a:bodyPr/>
-          <a:lstStyle/>
-          <a:p>
-            <a:endParaRPr lang="ko-KR" altLang="en-US"/>
-          </a:p>
-        </p:txBody>
-      </p:sp>
-      <p:sp>
-        <p:nvSpPr>
-          <p:cNvPr id="10" name="Text 8"/>
-          <p:cNvSpPr/>
-          <p:nvPr/>
-        </p:nvSpPr>
-        <p:spPr>
-          <a:xfrm>
-            <a:off x="777240" y="2629057"/>
-            <a:ext cx="7315200" cy="320040"/>
-          </a:xfrm>
-          <a:prstGeom prst="rect">
-            <a:avLst/>
-          </a:prstGeom>
-          <a:noFill/>
-          <a:ln/>
-        </p:spPr>
-        <p:txBody>
-          <a:bodyPr wrap="square" lIns="0" tIns="0" rIns="0" bIns="0" rtlCol="0" anchor="ctr"/>
-          <a:lstStyle/>
-          <a:p>
-            <a:pPr marL="0" indent="0">
-              <a:buNone/>
-            </a:pPr>
-            <a:r>
-              <a:rPr lang="en-US" sz="1300" dirty="0">
-                <a:solidFill>
-                  <a:srgbClr val="111111"/>
-                </a:solidFill>
-                <a:latin typeface="NanumGothicExtraBold" pitchFamily="34" charset="0"/>
-                <a:ea typeface="NanumGothicExtraBold" pitchFamily="34" charset="-122"/>
-                <a:cs typeface="NanumGothicExtraBold" pitchFamily="34" charset="-120"/>
-              </a:rPr>
-              <a:t>Workflow B:  디자인 중심 (Figma 활용)</a:t>
-            </a:r>
-            <a:endParaRPr lang="en-US" sz="1300" dirty="0"/>
-          </a:p>
-        </p:txBody>
-      </p:sp>
-      <p:sp>
-        <p:nvSpPr>
-          <p:cNvPr id="11" name="Text 9"/>
-          <p:cNvSpPr/>
-          <p:nvPr/>
-        </p:nvSpPr>
-        <p:spPr>
-          <a:xfrm>
-            <a:off x="777240" y="2994817"/>
-            <a:ext cx="7315200" cy="274320"/>
-          </a:xfrm>
-          <a:prstGeom prst="rect">
-            <a:avLst/>
-          </a:prstGeom>
-          <a:noFill/>
-          <a:ln/>
-        </p:spPr>
-        <p:txBody>
-          <a:bodyPr wrap="square" lIns="0" tIns="0" rIns="0" bIns="0" rtlCol="0" anchor="ctr"/>
-          <a:lstStyle/>
-          <a:p>
-            <a:pPr marL="0" indent="0">
-              <a:buNone/>
-            </a:pPr>
-            <a:r>
-              <a:rPr lang="en-US" sz="1200" dirty="0">
-                <a:solidFill>
-                  <a:srgbClr val="111111"/>
-                </a:solidFill>
-                <a:latin typeface="NanumGothic" pitchFamily="34" charset="0"/>
-                <a:ea typeface="NanumGothic" pitchFamily="34" charset="-122"/>
-                <a:cs typeface="NanumGothic" pitchFamily="34" charset="-120"/>
-              </a:rPr>
-              <a:t>Claude (PRD)  →  Figma AI / Make (와이어프레임)  →  Google Stitch (코드 변환)  →  Lovable (배포)</a:t>
-            </a:r>
-            <a:endParaRPr lang="en-US" sz="1200" dirty="0"/>
-          </a:p>
-        </p:txBody>
-      </p:sp>
-      <p:sp>
-        <p:nvSpPr>
-          <p:cNvPr id="12" name="Text 10"/>
-          <p:cNvSpPr/>
-          <p:nvPr/>
-        </p:nvSpPr>
-        <p:spPr>
-          <a:xfrm>
-            <a:off x="777240" y="3314857"/>
-            <a:ext cx="7315200" cy="274320"/>
-          </a:xfrm>
-          <a:prstGeom prst="rect">
-            <a:avLst/>
-          </a:prstGeom>
-          <a:noFill/>
-          <a:ln/>
-        </p:spPr>
-        <p:txBody>
-          <a:bodyPr wrap="square" lIns="0" tIns="0" rIns="0" bIns="0" rtlCol="0" anchor="ctr"/>
-          <a:lstStyle/>
-          <a:p>
-            <a:pPr marL="0" indent="0">
-              <a:buNone/>
-            </a:pPr>
-            <a:r>
-              <a:rPr lang="en-US" sz="1000" dirty="0">
-                <a:solidFill>
-                  <a:srgbClr val="6B7280"/>
-                </a:solidFill>
-                <a:latin typeface="NanumGothic" pitchFamily="34" charset="0"/>
-                <a:ea typeface="NanumGothic" pitchFamily="34" charset="-122"/>
-                <a:cs typeface="NanumGothic" pitchFamily="34" charset="-120"/>
-              </a:rPr>
-              <a:t>디자인 시스템이 중요한 B2C 서비스에 적합  |  Figma → 코드 자동 변환으로 개발 공수 절감</a:t>
+              <a:t>💡 Google AI Studio: Gemini 기반 프롬프트 테스트 · 멀티모달 분석에 활용 가능</a:t>
             </a:r>
             <a:endParaRPr lang="en-US" sz="1000" dirty="0"/>
           </a:p>
@@ -13393,7 +13111,7 @@
         </p:nvSpPr>
         <p:spPr>
           <a:xfrm>
-            <a:off x="640080" y="1370683"/>
+            <a:off x="640080" y="1051560"/>
             <a:ext cx="4754880" cy="502920"/>
           </a:xfrm>
           <a:prstGeom prst="rect">
@@ -13420,7 +13138,7 @@
         </p:nvSpPr>
         <p:spPr>
           <a:xfrm>
-            <a:off x="731520" y="1370683"/>
+            <a:off x="731520" y="1051560"/>
             <a:ext cx="1371600" cy="502920"/>
           </a:xfrm>
           <a:prstGeom prst="rect">
@@ -13459,7 +13177,7 @@
         </p:nvSpPr>
         <p:spPr>
           <a:xfrm>
-            <a:off x="2194560" y="1370683"/>
+            <a:off x="2194560" y="1051560"/>
             <a:ext cx="3108960" cy="502920"/>
           </a:xfrm>
           <a:prstGeom prst="rect">
@@ -13521,7 +13239,7 @@
         </p:nvSpPr>
         <p:spPr>
           <a:xfrm>
-            <a:off x="640080" y="1992475"/>
+            <a:off x="640080" y="1673352"/>
             <a:ext cx="4754880" cy="502920"/>
           </a:xfrm>
           <a:prstGeom prst="rect">
@@ -13548,7 +13266,7 @@
         </p:nvSpPr>
         <p:spPr>
           <a:xfrm>
-            <a:off x="731520" y="1992475"/>
+            <a:off x="731520" y="1673352"/>
             <a:ext cx="1371600" cy="502920"/>
           </a:xfrm>
           <a:prstGeom prst="rect">
@@ -13587,7 +13305,7 @@
         </p:nvSpPr>
         <p:spPr>
           <a:xfrm>
-            <a:off x="2194560" y="1992475"/>
+            <a:off x="2194560" y="1673352"/>
             <a:ext cx="3108960" cy="502920"/>
           </a:xfrm>
           <a:prstGeom prst="rect">
@@ -13649,7 +13367,7 @@
         </p:nvSpPr>
         <p:spPr>
           <a:xfrm>
-            <a:off x="640080" y="2614267"/>
+            <a:off x="640080" y="2295144"/>
             <a:ext cx="4754880" cy="502920"/>
           </a:xfrm>
           <a:prstGeom prst="rect">
@@ -13676,7 +13394,7 @@
         </p:nvSpPr>
         <p:spPr>
           <a:xfrm>
-            <a:off x="731520" y="2614267"/>
+            <a:off x="731520" y="2295144"/>
             <a:ext cx="1371600" cy="502920"/>
           </a:xfrm>
           <a:prstGeom prst="rect">
@@ -13715,7 +13433,7 @@
         </p:nvSpPr>
         <p:spPr>
           <a:xfrm>
-            <a:off x="2194560" y="2614267"/>
+            <a:off x="2194560" y="2295144"/>
             <a:ext cx="3108960" cy="502920"/>
           </a:xfrm>
           <a:prstGeom prst="rect">
@@ -13777,7 +13495,7 @@
         </p:nvSpPr>
         <p:spPr>
           <a:xfrm>
-            <a:off x="640080" y="3236059"/>
+            <a:off x="640080" y="2916936"/>
             <a:ext cx="4754880" cy="502920"/>
           </a:xfrm>
           <a:prstGeom prst="rect">
@@ -13804,7 +13522,7 @@
         </p:nvSpPr>
         <p:spPr>
           <a:xfrm>
-            <a:off x="731520" y="3236059"/>
+            <a:off x="731520" y="2916936"/>
             <a:ext cx="1371600" cy="502920"/>
           </a:xfrm>
           <a:prstGeom prst="rect">
@@ -13843,7 +13561,7 @@
         </p:nvSpPr>
         <p:spPr>
           <a:xfrm>
-            <a:off x="2194560" y="3236059"/>
+            <a:off x="2194560" y="2916936"/>
             <a:ext cx="3108960" cy="502920"/>
           </a:xfrm>
           <a:prstGeom prst="rect">
@@ -13905,7 +13623,7 @@
         </p:nvSpPr>
         <p:spPr>
           <a:xfrm>
-            <a:off x="5669280" y="1370683"/>
+            <a:off x="5669280" y="1051560"/>
             <a:ext cx="2834640" cy="2331720"/>
           </a:xfrm>
           <a:prstGeom prst="rect">
@@ -13937,7 +13655,7 @@
         </p:nvSpPr>
         <p:spPr>
           <a:xfrm>
-            <a:off x="5669280" y="1370683"/>
+            <a:off x="5669280" y="1051560"/>
             <a:ext cx="2834640" cy="2331720"/>
           </a:xfrm>
           <a:prstGeom prst="rect">
@@ -14274,28 +13992,7 @@
                 <a:ea typeface="NanumGothic" pitchFamily="34" charset="-122"/>
                 <a:cs typeface="NanumGothic" pitchFamily="34" charset="-120"/>
               </a:rPr>
-              <a:t>3가지 시대: </a:t>
-            </a:r>
-            <a:br>
-              <a:rPr lang="en-US" sz="1200" dirty="0">
-                <a:solidFill>
-                  <a:srgbClr val="2A2A2A"/>
-                </a:solidFill>
-                <a:latin typeface="NanumGothic" pitchFamily="34" charset="0"/>
-                <a:ea typeface="NanumGothic" pitchFamily="34" charset="-122"/>
-                <a:cs typeface="NanumGothic" pitchFamily="34" charset="-120"/>
-              </a:rPr>
-            </a:br>
-            <a:r>
-              <a:rPr lang="en-US" sz="1200" dirty="0">
-                <a:solidFill>
-                  <a:srgbClr val="2A2A2A"/>
-                </a:solidFill>
-                <a:latin typeface="NanumGothic" pitchFamily="34" charset="0"/>
-                <a:ea typeface="NanumGothic" pitchFamily="34" charset="-122"/>
-                <a:cs typeface="NanumGothic" pitchFamily="34" charset="-120"/>
-              </a:rPr>
-              <a:t>Feature → Product-Led → AI Native</a:t>
+              <a:t>3가지 시대: Feature → Product-Led → AI Native</a:t>
             </a:r>
             <a:endParaRPr lang="en-US" sz="1200" dirty="0"/>
           </a:p>
@@ -14736,7 +14433,7 @@
         </p:nvSpPr>
         <p:spPr>
           <a:xfrm>
-            <a:off x="640080" y="1394617"/>
+            <a:off x="640080" y="1143000"/>
             <a:ext cx="4572000" cy="2743200"/>
           </a:xfrm>
           <a:prstGeom prst="rect">
@@ -14863,7 +14560,7 @@
         </p:nvSpPr>
         <p:spPr>
           <a:xfrm>
-            <a:off x="5486400" y="1303177"/>
+            <a:off x="5486400" y="1051560"/>
             <a:ext cx="3017520" cy="2560320"/>
           </a:xfrm>
           <a:prstGeom prst="rect">
@@ -14895,7 +14592,7 @@
         </p:nvSpPr>
         <p:spPr>
           <a:xfrm>
-            <a:off x="5486400" y="1303177"/>
+            <a:off x="5486400" y="1051560"/>
             <a:ext cx="3017520" cy="2560320"/>
           </a:xfrm>
           <a:prstGeom prst="rect">
@@ -15571,7 +15268,7 @@
         </p:nvSpPr>
         <p:spPr>
           <a:xfrm>
-            <a:off x="640080" y="1260095"/>
+            <a:off x="640080" y="1069848"/>
             <a:ext cx="1005840" cy="384048"/>
           </a:xfrm>
           <a:prstGeom prst="rect">
@@ -15598,7 +15295,7 @@
         </p:nvSpPr>
         <p:spPr>
           <a:xfrm>
-            <a:off x="640080" y="1260095"/>
+            <a:off x="640080" y="1069848"/>
             <a:ext cx="1005840" cy="384048"/>
           </a:xfrm>
           <a:prstGeom prst="rect">
@@ -15637,7 +15334,7 @@
         </p:nvSpPr>
         <p:spPr>
           <a:xfrm>
-            <a:off x="1828800" y="1241807"/>
+            <a:off x="1828800" y="1051560"/>
             <a:ext cx="731520" cy="420624"/>
           </a:xfrm>
           <a:prstGeom prst="rect">
@@ -15676,7 +15373,7 @@
         </p:nvSpPr>
         <p:spPr>
           <a:xfrm>
-            <a:off x="2651760" y="1241807"/>
+            <a:off x="2651760" y="1051560"/>
             <a:ext cx="3200400" cy="420624"/>
           </a:xfrm>
           <a:prstGeom prst="rect">
@@ -15715,7 +15412,7 @@
         </p:nvSpPr>
         <p:spPr>
           <a:xfrm>
-            <a:off x="5943600" y="1241807"/>
+            <a:off x="5943600" y="1051560"/>
             <a:ext cx="2560320" cy="420624"/>
           </a:xfrm>
           <a:prstGeom prst="rect">
@@ -15754,7 +15451,7 @@
         </p:nvSpPr>
         <p:spPr>
           <a:xfrm>
-            <a:off x="640080" y="1790447"/>
+            <a:off x="640080" y="1600200"/>
             <a:ext cx="1005840" cy="384048"/>
           </a:xfrm>
           <a:prstGeom prst="rect">
@@ -15781,7 +15478,7 @@
         </p:nvSpPr>
         <p:spPr>
           <a:xfrm>
-            <a:off x="640080" y="1790447"/>
+            <a:off x="640080" y="1600200"/>
             <a:ext cx="1005840" cy="384048"/>
           </a:xfrm>
           <a:prstGeom prst="rect">
@@ -15820,7 +15517,7 @@
         </p:nvSpPr>
         <p:spPr>
           <a:xfrm>
-            <a:off x="1828800" y="1772159"/>
+            <a:off x="1828800" y="1581912"/>
             <a:ext cx="731520" cy="420624"/>
           </a:xfrm>
           <a:prstGeom prst="rect">
@@ -15859,7 +15556,7 @@
         </p:nvSpPr>
         <p:spPr>
           <a:xfrm>
-            <a:off x="2651760" y="1772159"/>
+            <a:off x="2651760" y="1581912"/>
             <a:ext cx="3200400" cy="420624"/>
           </a:xfrm>
           <a:prstGeom prst="rect">
@@ -15898,7 +15595,7 @@
         </p:nvSpPr>
         <p:spPr>
           <a:xfrm>
-            <a:off x="5943600" y="1772159"/>
+            <a:off x="5943600" y="1581912"/>
             <a:ext cx="2560320" cy="420624"/>
           </a:xfrm>
           <a:prstGeom prst="rect">
@@ -15937,7 +15634,7 @@
         </p:nvSpPr>
         <p:spPr>
           <a:xfrm>
-            <a:off x="640080" y="2320799"/>
+            <a:off x="640080" y="2130552"/>
             <a:ext cx="1005840" cy="384048"/>
           </a:xfrm>
           <a:prstGeom prst="rect">
@@ -15964,7 +15661,7 @@
         </p:nvSpPr>
         <p:spPr>
           <a:xfrm>
-            <a:off x="640080" y="2320799"/>
+            <a:off x="640080" y="2130552"/>
             <a:ext cx="1005840" cy="384048"/>
           </a:xfrm>
           <a:prstGeom prst="rect">
@@ -16003,7 +15700,7 @@
         </p:nvSpPr>
         <p:spPr>
           <a:xfrm>
-            <a:off x="1828800" y="2302511"/>
+            <a:off x="1828800" y="2112264"/>
             <a:ext cx="731520" cy="420624"/>
           </a:xfrm>
           <a:prstGeom prst="rect">
@@ -16042,7 +15739,7 @@
         </p:nvSpPr>
         <p:spPr>
           <a:xfrm>
-            <a:off x="2651760" y="2302511"/>
+            <a:off x="2651760" y="2112264"/>
             <a:ext cx="3200400" cy="420624"/>
           </a:xfrm>
           <a:prstGeom prst="rect">
@@ -16081,7 +15778,7 @@
         </p:nvSpPr>
         <p:spPr>
           <a:xfrm>
-            <a:off x="5943600" y="2302511"/>
+            <a:off x="5943600" y="2112264"/>
             <a:ext cx="2560320" cy="420624"/>
           </a:xfrm>
           <a:prstGeom prst="rect">
@@ -16120,7 +15817,7 @@
         </p:nvSpPr>
         <p:spPr>
           <a:xfrm>
-            <a:off x="640080" y="2851151"/>
+            <a:off x="640080" y="2660904"/>
             <a:ext cx="1005840" cy="384048"/>
           </a:xfrm>
           <a:prstGeom prst="rect">
@@ -16147,7 +15844,7 @@
         </p:nvSpPr>
         <p:spPr>
           <a:xfrm>
-            <a:off x="640080" y="2851151"/>
+            <a:off x="640080" y="2660904"/>
             <a:ext cx="1005840" cy="384048"/>
           </a:xfrm>
           <a:prstGeom prst="rect">
@@ -16186,7 +15883,7 @@
         </p:nvSpPr>
         <p:spPr>
           <a:xfrm>
-            <a:off x="1828800" y="2832863"/>
+            <a:off x="1828800" y="2642616"/>
             <a:ext cx="731520" cy="420624"/>
           </a:xfrm>
           <a:prstGeom prst="rect">
@@ -16225,7 +15922,7 @@
         </p:nvSpPr>
         <p:spPr>
           <a:xfrm>
-            <a:off x="2651760" y="2832863"/>
+            <a:off x="2651760" y="2642616"/>
             <a:ext cx="3200400" cy="420624"/>
           </a:xfrm>
           <a:prstGeom prst="rect">
@@ -16264,7 +15961,7 @@
         </p:nvSpPr>
         <p:spPr>
           <a:xfrm>
-            <a:off x="5943600" y="2832863"/>
+            <a:off x="5943600" y="2642616"/>
             <a:ext cx="2560320" cy="420624"/>
           </a:xfrm>
           <a:prstGeom prst="rect">
@@ -16303,7 +16000,7 @@
         </p:nvSpPr>
         <p:spPr>
           <a:xfrm>
-            <a:off x="640080" y="3381503"/>
+            <a:off x="640080" y="3191256"/>
             <a:ext cx="1005840" cy="384048"/>
           </a:xfrm>
           <a:prstGeom prst="rect">
@@ -16330,7 +16027,7 @@
         </p:nvSpPr>
         <p:spPr>
           <a:xfrm>
-            <a:off x="640080" y="3381503"/>
+            <a:off x="640080" y="3191256"/>
             <a:ext cx="1005840" cy="384048"/>
           </a:xfrm>
           <a:prstGeom prst="rect">
@@ -16369,7 +16066,7 @@
         </p:nvSpPr>
         <p:spPr>
           <a:xfrm>
-            <a:off x="1828800" y="3363215"/>
+            <a:off x="1828800" y="3172968"/>
             <a:ext cx="731520" cy="420624"/>
           </a:xfrm>
           <a:prstGeom prst="rect">
@@ -16408,7 +16105,7 @@
         </p:nvSpPr>
         <p:spPr>
           <a:xfrm>
-            <a:off x="2651760" y="3363215"/>
+            <a:off x="2651760" y="3172968"/>
             <a:ext cx="3200400" cy="420624"/>
           </a:xfrm>
           <a:prstGeom prst="rect">
@@ -16447,7 +16144,7 @@
         </p:nvSpPr>
         <p:spPr>
           <a:xfrm>
-            <a:off x="5943600" y="3363215"/>
+            <a:off x="5943600" y="3172968"/>
             <a:ext cx="2560320" cy="420624"/>
           </a:xfrm>
           <a:prstGeom prst="rect">
@@ -16612,7 +16309,7 @@
         </p:nvSpPr>
         <p:spPr>
           <a:xfrm>
-            <a:off x="640080" y="1217259"/>
+            <a:off x="640080" y="1051560"/>
             <a:ext cx="3840480" cy="320040"/>
           </a:xfrm>
           <a:prstGeom prst="rect">
@@ -16651,7 +16348,7 @@
         </p:nvSpPr>
         <p:spPr>
           <a:xfrm>
-            <a:off x="640080" y="1583019"/>
+            <a:off x="640080" y="1417320"/>
             <a:ext cx="3840480" cy="320040"/>
           </a:xfrm>
           <a:prstGeom prst="rect">
@@ -16690,7 +16387,7 @@
         </p:nvSpPr>
         <p:spPr>
           <a:xfrm>
-            <a:off x="640080" y="1948779"/>
+            <a:off x="640080" y="1783080"/>
             <a:ext cx="3840480" cy="320040"/>
           </a:xfrm>
           <a:prstGeom prst="rect">
@@ -16729,7 +16426,7 @@
         </p:nvSpPr>
         <p:spPr>
           <a:xfrm>
-            <a:off x="640080" y="2314539"/>
+            <a:off x="640080" y="2148840"/>
             <a:ext cx="3840480" cy="320040"/>
           </a:xfrm>
           <a:prstGeom prst="rect">
@@ -16768,7 +16465,7 @@
         </p:nvSpPr>
         <p:spPr>
           <a:xfrm>
-            <a:off x="4754880" y="1217259"/>
+            <a:off x="4754880" y="1051560"/>
             <a:ext cx="3749040" cy="1051560"/>
           </a:xfrm>
           <a:prstGeom prst="rect">
@@ -16795,7 +16492,7 @@
         </p:nvSpPr>
         <p:spPr>
           <a:xfrm>
-            <a:off x="4937760" y="1262979"/>
+            <a:off x="4937760" y="1097280"/>
             <a:ext cx="3383280" cy="274320"/>
           </a:xfrm>
           <a:prstGeom prst="rect">
@@ -16834,7 +16531,7 @@
         </p:nvSpPr>
         <p:spPr>
           <a:xfrm>
-            <a:off x="4937760" y="1583019"/>
+            <a:off x="4937760" y="1417320"/>
             <a:ext cx="3383280" cy="594360"/>
           </a:xfrm>
           <a:prstGeom prst="rect">
@@ -16896,7 +16593,7 @@
         </p:nvSpPr>
         <p:spPr>
           <a:xfrm>
-            <a:off x="4754880" y="2451699"/>
+            <a:off x="4754880" y="2286000"/>
             <a:ext cx="3749040" cy="1051560"/>
           </a:xfrm>
           <a:prstGeom prst="rect">
@@ -16923,7 +16620,7 @@
         </p:nvSpPr>
         <p:spPr>
           <a:xfrm>
-            <a:off x="4754880" y="2451699"/>
+            <a:off x="4754880" y="2286000"/>
             <a:ext cx="36576" cy="1051560"/>
           </a:xfrm>
           <a:prstGeom prst="rect">
@@ -16950,7 +16647,7 @@
         </p:nvSpPr>
         <p:spPr>
           <a:xfrm>
-            <a:off x="4983480" y="2497419"/>
+            <a:off x="4983480" y="2331720"/>
             <a:ext cx="3383280" cy="274320"/>
           </a:xfrm>
           <a:prstGeom prst="rect">
@@ -16989,7 +16686,7 @@
         </p:nvSpPr>
         <p:spPr>
           <a:xfrm>
-            <a:off x="4983480" y="2817459"/>
+            <a:off x="4983480" y="2651760"/>
             <a:ext cx="3383280" cy="594360"/>
           </a:xfrm>
           <a:prstGeom prst="rect">
@@ -17043,37 +16740,77 @@
           </a:p>
         </p:txBody>
       </p:sp>
-      <p:pic>
-        <p:nvPicPr>
-          <p:cNvPr id="18" name="그림 17">
-            <a:extLst>
-              <a:ext uri="{FF2B5EF4-FFF2-40B4-BE49-F238E27FC236}">
-                <a16:creationId xmlns:a16="http://schemas.microsoft.com/office/drawing/2014/main" id="{D5293414-A5CD-E04E-CF85-73D94D1B7167}"/>
-              </a:ext>
-            </a:extLst>
-          </p:cNvPr>
-          <p:cNvPicPr>
-            <a:picLocks noChangeAspect="1"/>
-          </p:cNvPicPr>
-          <p:nvPr/>
-        </p:nvPicPr>
-        <p:blipFill>
-          <a:blip r:embed="rId3"/>
-          <a:srcRect b="31537"/>
-          <a:stretch>
-            <a:fillRect/>
-          </a:stretch>
-        </p:blipFill>
-        <p:spPr>
-          <a:xfrm>
-            <a:off x="640080" y="2634579"/>
-            <a:ext cx="2800306" cy="1987736"/>
-          </a:xfrm>
-          <a:prstGeom prst="rect">
-            <a:avLst/>
-          </a:prstGeom>
-        </p:spPr>
-      </p:pic>
+      <p:sp>
+        <p:nvSpPr>
+          <p:cNvPr id="16" name="Shape 14"/>
+          <p:cNvSpPr/>
+          <p:nvPr/>
+        </p:nvSpPr>
+        <p:spPr>
+          <a:xfrm>
+            <a:off x="640080" y="3520440"/>
+            <a:ext cx="3840480" cy="502920"/>
+          </a:xfrm>
+          <a:prstGeom prst="rect">
+            <a:avLst/>
+          </a:prstGeom>
+          <a:solidFill>
+            <a:srgbClr val="E5E7EB"/>
+          </a:solidFill>
+          <a:ln w="12700">
+            <a:solidFill>
+              <a:srgbClr val="6B7280"/>
+            </a:solidFill>
+            <a:prstDash val="dash"/>
+          </a:ln>
+        </p:spPr>
+        <p:txBody>
+          <a:bodyPr/>
+          <a:lstStyle/>
+          <a:p>
+            <a:endParaRPr lang="ko-KR" altLang="en-US"/>
+          </a:p>
+        </p:txBody>
+      </p:sp>
+      <p:sp>
+        <p:nvSpPr>
+          <p:cNvPr id="17" name="Text 15"/>
+          <p:cNvSpPr/>
+          <p:nvPr/>
+        </p:nvSpPr>
+        <p:spPr>
+          <a:xfrm>
+            <a:off x="640080" y="3520440"/>
+            <a:ext cx="3840480" cy="502920"/>
+          </a:xfrm>
+          <a:prstGeom prst="rect">
+            <a:avLst/>
+          </a:prstGeom>
+          <a:noFill/>
+          <a:ln/>
+        </p:spPr>
+        <p:txBody>
+          <a:bodyPr wrap="square" lIns="0" tIns="0" rIns="0" bIns="0" rtlCol="0" anchor="ctr"/>
+          <a:lstStyle/>
+          <a:p>
+            <a:pPr marL="0" indent="0" algn="ctr">
+              <a:buNone/>
+            </a:pPr>
+            <a:r>
+              <a:rPr lang="en-US" sz="1100" dirty="0">
+                <a:solidFill>
+                  <a:srgbClr val="6B7280"/>
+                </a:solidFill>
+                <a:latin typeface="NanumGothic" pitchFamily="34" charset="0"/>
+                <a:ea typeface="NanumGothic" pitchFamily="34" charset="-122"/>
+                <a:cs typeface="NanumGothic" pitchFamily="34" charset="-120"/>
+              </a:rPr>
+              <a:t>📷  Manyfast.io 로그인 화면 캡처</a:t>
+            </a:r>
+            <a:endParaRPr lang="en-US" sz="1100" dirty="0"/>
+          </a:p>
+        </p:txBody>
+      </p:sp>
     </p:spTree>
   </p:cSld>
   <p:clrMapOvr>
@@ -17208,7 +16945,7 @@
         </p:nvSpPr>
         <p:spPr>
           <a:xfrm>
-            <a:off x="822960" y="1257457"/>
+            <a:off x="822960" y="1005840"/>
             <a:ext cx="7498080" cy="2560320"/>
           </a:xfrm>
           <a:prstGeom prst="rect">
@@ -17235,7 +16972,7 @@
         </p:nvSpPr>
         <p:spPr>
           <a:xfrm>
-            <a:off x="1097280" y="1440337"/>
+            <a:off x="1097280" y="1188720"/>
             <a:ext cx="6949440" cy="365760"/>
           </a:xfrm>
           <a:prstGeom prst="rect">
@@ -17274,7 +17011,7 @@
         </p:nvSpPr>
         <p:spPr>
           <a:xfrm>
-            <a:off x="1097280" y="1851817"/>
+            <a:off x="1097280" y="1600200"/>
             <a:ext cx="6949440" cy="365760"/>
           </a:xfrm>
           <a:prstGeom prst="rect">
@@ -17313,7 +17050,7 @@
         </p:nvSpPr>
         <p:spPr>
           <a:xfrm>
-            <a:off x="1097280" y="2263297"/>
+            <a:off x="1097280" y="2011680"/>
             <a:ext cx="6949440" cy="365760"/>
           </a:xfrm>
           <a:prstGeom prst="rect">
@@ -17352,7 +17089,7 @@
         </p:nvSpPr>
         <p:spPr>
           <a:xfrm>
-            <a:off x="1097280" y="2674777"/>
+            <a:off x="1097280" y="2423160"/>
             <a:ext cx="6949440" cy="365760"/>
           </a:xfrm>
           <a:prstGeom prst="rect">
@@ -17391,7 +17128,7 @@
         </p:nvSpPr>
         <p:spPr>
           <a:xfrm>
-            <a:off x="1097280" y="3086257"/>
+            <a:off x="1097280" y="2834640"/>
             <a:ext cx="6949440" cy="365760"/>
           </a:xfrm>
           <a:prstGeom prst="rect">
@@ -17430,7 +17167,7 @@
         </p:nvSpPr>
         <p:spPr>
           <a:xfrm>
-            <a:off x="640080" y="4046377"/>
+            <a:off x="640080" y="3794760"/>
             <a:ext cx="7863840" cy="274320"/>
           </a:xfrm>
           <a:prstGeom prst="rect">
@@ -17595,7 +17332,7 @@
         </p:nvSpPr>
         <p:spPr>
           <a:xfrm>
-            <a:off x="822960" y="1361784"/>
+            <a:off x="822960" y="1005840"/>
             <a:ext cx="7498080" cy="2560320"/>
           </a:xfrm>
           <a:prstGeom prst="rect">
@@ -17622,7 +17359,7 @@
         </p:nvSpPr>
         <p:spPr>
           <a:xfrm>
-            <a:off x="822960" y="1361784"/>
+            <a:off x="822960" y="1005840"/>
             <a:ext cx="36576" cy="2560320"/>
           </a:xfrm>
           <a:prstGeom prst="rect">
@@ -17649,7 +17386,7 @@
         </p:nvSpPr>
         <p:spPr>
           <a:xfrm>
-            <a:off x="1097280" y="1544664"/>
+            <a:off x="1097280" y="1188720"/>
             <a:ext cx="6949440" cy="365760"/>
           </a:xfrm>
           <a:prstGeom prst="rect">
@@ -17699,7 +17436,7 @@
         </p:nvSpPr>
         <p:spPr>
           <a:xfrm>
-            <a:off x="1097280" y="1956144"/>
+            <a:off x="1097280" y="1600200"/>
             <a:ext cx="6949440" cy="365760"/>
           </a:xfrm>
           <a:prstGeom prst="rect">
@@ -17749,7 +17486,7 @@
         </p:nvSpPr>
         <p:spPr>
           <a:xfrm>
-            <a:off x="1097280" y="2367624"/>
+            <a:off x="1097280" y="2011680"/>
             <a:ext cx="6949440" cy="365760"/>
           </a:xfrm>
           <a:prstGeom prst="rect">
@@ -17799,7 +17536,7 @@
         </p:nvSpPr>
         <p:spPr>
           <a:xfrm>
-            <a:off x="1097280" y="2779104"/>
+            <a:off x="1097280" y="2423160"/>
             <a:ext cx="6949440" cy="365760"/>
           </a:xfrm>
           <a:prstGeom prst="rect">
@@ -17849,7 +17586,7 @@
         </p:nvSpPr>
         <p:spPr>
           <a:xfrm>
-            <a:off x="1097280" y="3190584"/>
+            <a:off x="1097280" y="2834640"/>
             <a:ext cx="6949440" cy="365760"/>
           </a:xfrm>
           <a:prstGeom prst="rect">
@@ -18025,7 +17762,7 @@
         </p:nvSpPr>
         <p:spPr>
           <a:xfrm>
-            <a:off x="640080" y="1409652"/>
+            <a:off x="640080" y="1188720"/>
             <a:ext cx="7863840" cy="548640"/>
           </a:xfrm>
           <a:prstGeom prst="rect">
@@ -18042,7 +17779,7 @@
               <a:buNone/>
             </a:pPr>
             <a:r>
-              <a:rPr lang="en-US" sz="2800" dirty="0" err="1">
+              <a:rPr lang="en-US" sz="2800" dirty="0">
                 <a:solidFill>
                   <a:srgbClr val="111111"/>
                 </a:solidFill>
@@ -18050,51 +17787,7 @@
                 <a:ea typeface="NanumGothicExtraBold" pitchFamily="34" charset="-122"/>
                 <a:cs typeface="NanumGothicExtraBold" pitchFamily="34" charset="-120"/>
               </a:rPr>
-              <a:t>옆</a:t>
-            </a:r>
-            <a:r>
-              <a:rPr lang="en-US" sz="2800" dirty="0">
-                <a:solidFill>
-                  <a:srgbClr val="111111"/>
-                </a:solidFill>
-                <a:latin typeface="NanumGothicExtraBold" pitchFamily="34" charset="0"/>
-                <a:ea typeface="NanumGothicExtraBold" pitchFamily="34" charset="-122"/>
-                <a:cs typeface="NanumGothicExtraBold" pitchFamily="34" charset="-120"/>
-              </a:rPr>
-              <a:t> </a:t>
-            </a:r>
-            <a:r>
-              <a:rPr lang="en-US" sz="2800" dirty="0" err="1">
-                <a:solidFill>
-                  <a:srgbClr val="111111"/>
-                </a:solidFill>
-                <a:latin typeface="NanumGothicExtraBold" pitchFamily="34" charset="0"/>
-                <a:ea typeface="NanumGothicExtraBold" pitchFamily="34" charset="-122"/>
-                <a:cs typeface="NanumGothicExtraBold" pitchFamily="34" charset="-120"/>
-              </a:rPr>
-              <a:t>사람</a:t>
-            </a:r>
-            <a:r>
-              <a:rPr lang="ko-KR" altLang="en-US" sz="2800" dirty="0">
-                <a:solidFill>
-                  <a:srgbClr val="111111"/>
-                </a:solidFill>
-                <a:latin typeface="NanumGothicExtraBold" pitchFamily="34" charset="0"/>
-                <a:ea typeface="NanumGothicExtraBold" pitchFamily="34" charset="-122"/>
-                <a:cs typeface="NanumGothicExtraBold" pitchFamily="34" charset="-120"/>
-              </a:rPr>
-              <a:t>에게</a:t>
-            </a:r>
-            <a:r>
-              <a:rPr lang="en-US" sz="2800" dirty="0">
-                <a:solidFill>
-                  <a:srgbClr val="111111"/>
-                </a:solidFill>
-                <a:latin typeface="NanumGothicExtraBold" pitchFamily="34" charset="0"/>
-                <a:ea typeface="NanumGothicExtraBold" pitchFamily="34" charset="-122"/>
-                <a:cs typeface="NanumGothicExtraBold" pitchFamily="34" charset="-120"/>
-              </a:rPr>
-              <a:t> 보여주세요</a:t>
+              <a:t>옆 사람에게 보여주세요</a:t>
             </a:r>
             <a:endParaRPr lang="en-US" sz="2800" dirty="0"/>
           </a:p>
@@ -18108,7 +17801,7 @@
         </p:nvSpPr>
         <p:spPr>
           <a:xfrm>
-            <a:off x="1828800" y="2232612"/>
+            <a:off x="1828800" y="2011680"/>
             <a:ext cx="5486400" cy="1097280"/>
           </a:xfrm>
           <a:prstGeom prst="rect">
@@ -18135,7 +17828,7 @@
         </p:nvSpPr>
         <p:spPr>
           <a:xfrm>
-            <a:off x="2011680" y="2324052"/>
+            <a:off x="2011680" y="2103120"/>
             <a:ext cx="5120640" cy="365760"/>
           </a:xfrm>
           <a:prstGeom prst="rect">
@@ -18174,7 +17867,7 @@
         </p:nvSpPr>
         <p:spPr>
           <a:xfrm>
-            <a:off x="2011680" y="2826972"/>
+            <a:off x="2011680" y="2606040"/>
             <a:ext cx="5120640" cy="320040"/>
           </a:xfrm>
           <a:prstGeom prst="rect">
@@ -18378,7 +18071,7 @@
         </p:nvSpPr>
         <p:spPr>
           <a:xfrm>
-            <a:off x="640080" y="1394617"/>
+            <a:off x="640080" y="1143000"/>
             <a:ext cx="4572000" cy="2743200"/>
           </a:xfrm>
           <a:prstGeom prst="rect">
@@ -18466,64 +18159,97 @@
                 <a:ea typeface="NanumGothic" pitchFamily="34" charset="-122"/>
                 <a:cs typeface="NanumGothic" pitchFamily="34" charset="-120"/>
               </a:rPr>
-              <a:t>4.  핵심 기능 부분만 복사 → </a:t>
-            </a:r>
-            <a:r>
-              <a:rPr lang="en-US" sz="1400" b="1" dirty="0" err="1">
-                <a:solidFill>
-                  <a:srgbClr val="111111"/>
+              <a:t>4.  핵심 기능 부분만 복사 → 메모장 저장</a:t>
+            </a:r>
+            <a:endParaRPr lang="en-US" sz="1400" dirty="0"/>
+          </a:p>
+        </p:txBody>
+      </p:sp>
+      <p:sp>
+        <p:nvSpPr>
+          <p:cNvPr id="6" name="Shape 4"/>
+          <p:cNvSpPr/>
+          <p:nvPr/>
+        </p:nvSpPr>
+        <p:spPr>
+          <a:xfrm>
+            <a:off x="5486400" y="1051560"/>
+            <a:ext cx="3017520" cy="1828800"/>
+          </a:xfrm>
+          <a:prstGeom prst="rect">
+            <a:avLst/>
+          </a:prstGeom>
+          <a:solidFill>
+            <a:srgbClr val="E5E7EB"/>
+          </a:solidFill>
+          <a:ln w="12700">
+            <a:solidFill>
+              <a:srgbClr val="6B7280"/>
+            </a:solidFill>
+            <a:prstDash val="dash"/>
+          </a:ln>
+        </p:spPr>
+        <p:txBody>
+          <a:bodyPr/>
+          <a:lstStyle/>
+          <a:p>
+            <a:endParaRPr lang="ko-KR" altLang="en-US"/>
+          </a:p>
+        </p:txBody>
+      </p:sp>
+      <p:sp>
+        <p:nvSpPr>
+          <p:cNvPr id="7" name="Text 5"/>
+          <p:cNvSpPr/>
+          <p:nvPr/>
+        </p:nvSpPr>
+        <p:spPr>
+          <a:xfrm>
+            <a:off x="5486400" y="1051560"/>
+            <a:ext cx="3017520" cy="1828800"/>
+          </a:xfrm>
+          <a:prstGeom prst="rect">
+            <a:avLst/>
+          </a:prstGeom>
+          <a:noFill/>
+          <a:ln/>
+        </p:spPr>
+        <p:txBody>
+          <a:bodyPr wrap="square" lIns="0" tIns="0" rIns="0" bIns="0" rtlCol="0" anchor="ctr"/>
+          <a:lstStyle/>
+          <a:p>
+            <a:pPr marL="0" indent="0" algn="ctr">
+              <a:buNone/>
+            </a:pPr>
+            <a:r>
+              <a:rPr lang="en-US" sz="1100" dirty="0">
+                <a:solidFill>
+                  <a:srgbClr val="6B7280"/>
                 </a:solidFill>
                 <a:latin typeface="NanumGothic" pitchFamily="34" charset="0"/>
                 <a:ea typeface="NanumGothic" pitchFamily="34" charset="-122"/>
                 <a:cs typeface="NanumGothic" pitchFamily="34" charset="-120"/>
               </a:rPr>
-              <a:t>메모장</a:t>
-            </a:r>
-            <a:r>
-              <a:rPr lang="en-US" altLang="ko-KR" sz="1400" b="1" dirty="0">
-                <a:solidFill>
-                  <a:srgbClr val="111111"/>
+              <a:t>📷  Manyfast.io PRD 생성 화면 캡처</a:t>
+            </a:r>
+            <a:endParaRPr lang="en-US" sz="1100" dirty="0"/>
+          </a:p>
+          <a:p>
+            <a:pPr marL="0" indent="0" algn="ctr">
+              <a:buNone/>
+            </a:pPr>
+            <a:r>
+              <a:rPr lang="en-US" sz="1100" dirty="0">
+                <a:solidFill>
+                  <a:srgbClr val="6B7280"/>
                 </a:solidFill>
                 <a:latin typeface="NanumGothic" pitchFamily="34" charset="0"/>
                 <a:ea typeface="NanumGothic" pitchFamily="34" charset="-122"/>
                 <a:cs typeface="NanumGothic" pitchFamily="34" charset="-120"/>
               </a:rPr>
-              <a:t>/</a:t>
-            </a:r>
-            <a:r>
-              <a:rPr lang="ko-KR" altLang="en-US" sz="1400" b="1" dirty="0" err="1">
-                <a:solidFill>
-                  <a:srgbClr val="111111"/>
-                </a:solidFill>
-                <a:latin typeface="NanumGothic" pitchFamily="34" charset="0"/>
-                <a:ea typeface="NanumGothic" pitchFamily="34" charset="-122"/>
-                <a:cs typeface="NanumGothic" pitchFamily="34" charset="-120"/>
-              </a:rPr>
-              <a:t>노션</a:t>
-            </a:r>
-            <a:r>
-              <a:rPr lang="ko-KR" altLang="en-US" sz="1400" b="1" dirty="0">
-                <a:solidFill>
-                  <a:srgbClr val="111111"/>
-                </a:solidFill>
-                <a:latin typeface="NanumGothic" pitchFamily="34" charset="0"/>
-                <a:ea typeface="NanumGothic" pitchFamily="34" charset="-122"/>
-                <a:cs typeface="NanumGothic" pitchFamily="34" charset="-120"/>
-              </a:rPr>
-              <a:t> 등</a:t>
-            </a:r>
-            <a:r>
-              <a:rPr lang="en-US" sz="1400" b="1" dirty="0">
-                <a:solidFill>
-                  <a:srgbClr val="111111"/>
-                </a:solidFill>
-                <a:latin typeface="NanumGothic" pitchFamily="34" charset="0"/>
-                <a:ea typeface="NanumGothic" pitchFamily="34" charset="-122"/>
-                <a:cs typeface="NanumGothic" pitchFamily="34" charset="-120"/>
-              </a:rPr>
-              <a:t> 저장</a:t>
-            </a:r>
-            <a:endParaRPr lang="en-US" sz="1400" dirty="0"/>
+              <a:t>(입력 → 결과)</a:t>
+            </a:r>
+            <a:endParaRPr lang="en-US" sz="1100" dirty="0"/>
           </a:p>
         </p:txBody>
       </p:sp>
@@ -18535,7 +18261,7 @@
         </p:nvSpPr>
         <p:spPr>
           <a:xfrm>
-            <a:off x="640080" y="3543457"/>
+            <a:off x="640080" y="3291840"/>
             <a:ext cx="7863840" cy="502920"/>
           </a:xfrm>
           <a:prstGeom prst="rect">
@@ -18550,7 +18276,7 @@
           <a:bodyPr/>
           <a:lstStyle/>
           <a:p>
-            <a:endParaRPr lang="ko-KR" altLang="en-US" dirty="0"/>
+            <a:endParaRPr lang="ko-KR" altLang="en-US"/>
           </a:p>
         </p:txBody>
       </p:sp>
@@ -18562,7 +18288,7 @@
         </p:nvSpPr>
         <p:spPr>
           <a:xfrm>
-            <a:off x="777240" y="3543457"/>
+            <a:off x="777240" y="3291840"/>
             <a:ext cx="7589520" cy="502920"/>
           </a:xfrm>
           <a:prstGeom prst="rect">
@@ -18581,7 +18307,7 @@
             <a:r>
               <a:rPr lang="en-US" sz="1200" dirty="0">
                 <a:solidFill>
-                  <a:srgbClr val="FF0000"/>
+                  <a:srgbClr val="92400E"/>
                 </a:solidFill>
                 <a:latin typeface="NanumGothic Bold" pitchFamily="34" charset="0"/>
                 <a:ea typeface="NanumGothic Bold" pitchFamily="34" charset="-122"/>
@@ -18589,44 +18315,10 @@
               </a:rPr>
               <a:t>⚠️  PRD 전체 복사 금지 — 핵심 기능 3줄 요약만 저장 (토큰 절감)</a:t>
             </a:r>
-            <a:endParaRPr lang="en-US" sz="1200" dirty="0">
-              <a:solidFill>
-                <a:srgbClr val="FF0000"/>
-              </a:solidFill>
-            </a:endParaRPr>
-          </a:p>
-        </p:txBody>
-      </p:sp>
-      <p:pic>
-        <p:nvPicPr>
-          <p:cNvPr id="10" name="그림 9">
-            <a:extLst>
-              <a:ext uri="{FF2B5EF4-FFF2-40B4-BE49-F238E27FC236}">
-                <a16:creationId xmlns:a16="http://schemas.microsoft.com/office/drawing/2014/main" id="{C4533DA6-2910-32F6-C1A8-7045F5B03858}"/>
-              </a:ext>
-            </a:extLst>
-          </p:cNvPr>
-          <p:cNvPicPr>
-            <a:picLocks noChangeAspect="1"/>
-          </p:cNvPicPr>
-          <p:nvPr/>
-        </p:nvPicPr>
-        <p:blipFill>
-          <a:blip r:embed="rId3"/>
-          <a:stretch>
-            <a:fillRect/>
-          </a:stretch>
-        </p:blipFill>
-        <p:spPr>
-          <a:xfrm>
-            <a:off x="5349240" y="1281220"/>
-            <a:ext cx="3080165" cy="3193708"/>
-          </a:xfrm>
-          <a:prstGeom prst="rect">
-            <a:avLst/>
-          </a:prstGeom>
-        </p:spPr>
-      </p:pic>
+            <a:endParaRPr lang="en-US" sz="1200" dirty="0"/>
+          </a:p>
+        </p:txBody>
+      </p:sp>
     </p:spTree>
   </p:cSld>
   <p:clrMapOvr>
@@ -18761,7 +18453,7 @@
         </p:nvSpPr>
         <p:spPr>
           <a:xfrm>
-            <a:off x="640080" y="1490045"/>
+            <a:off x="640080" y="1097280"/>
             <a:ext cx="7863840" cy="320040"/>
           </a:xfrm>
           <a:prstGeom prst="rect">
@@ -18803,7 +18495,7 @@
         </p:nvSpPr>
         <p:spPr>
           <a:xfrm>
-            <a:off x="640080" y="1444325"/>
+            <a:off x="640080" y="1051560"/>
             <a:ext cx="7863840" cy="640080"/>
           </a:xfrm>
           <a:prstGeom prst="rect">
@@ -18830,7 +18522,7 @@
         </p:nvSpPr>
         <p:spPr>
           <a:xfrm>
-            <a:off x="731520" y="1444325"/>
+            <a:off x="731520" y="1051560"/>
             <a:ext cx="7680960" cy="274320"/>
           </a:xfrm>
           <a:prstGeom prst="rect">
@@ -18869,7 +18561,7 @@
         </p:nvSpPr>
         <p:spPr>
           <a:xfrm>
-            <a:off x="914400" y="1736933"/>
+            <a:off x="914400" y="1344168"/>
             <a:ext cx="7406640" cy="274320"/>
           </a:xfrm>
           <a:prstGeom prst="rect">
@@ -18952,7 +18644,7 @@
         </p:nvSpPr>
         <p:spPr>
           <a:xfrm>
-            <a:off x="640080" y="2221565"/>
+            <a:off x="640080" y="1828800"/>
             <a:ext cx="7863840" cy="640080"/>
           </a:xfrm>
           <a:prstGeom prst="rect">
@@ -18979,7 +18671,7 @@
         </p:nvSpPr>
         <p:spPr>
           <a:xfrm>
-            <a:off x="731520" y="2221565"/>
+            <a:off x="731520" y="1828800"/>
             <a:ext cx="7680960" cy="274320"/>
           </a:xfrm>
           <a:prstGeom prst="rect">
@@ -19018,7 +18710,7 @@
         </p:nvSpPr>
         <p:spPr>
           <a:xfrm>
-            <a:off x="914400" y="2514173"/>
+            <a:off x="914400" y="2121408"/>
             <a:ext cx="7406640" cy="274320"/>
           </a:xfrm>
           <a:prstGeom prst="rect">
@@ -19101,7 +18793,7 @@
         </p:nvSpPr>
         <p:spPr>
           <a:xfrm>
-            <a:off x="640080" y="2998805"/>
+            <a:off x="640080" y="2606040"/>
             <a:ext cx="7863840" cy="640080"/>
           </a:xfrm>
           <a:prstGeom prst="rect">
@@ -19128,7 +18820,7 @@
         </p:nvSpPr>
         <p:spPr>
           <a:xfrm>
-            <a:off x="731520" y="2998805"/>
+            <a:off x="731520" y="2606040"/>
             <a:ext cx="7680960" cy="274320"/>
           </a:xfrm>
           <a:prstGeom prst="rect">
@@ -19167,7 +18859,7 @@
         </p:nvSpPr>
         <p:spPr>
           <a:xfrm>
-            <a:off x="914400" y="3291413"/>
+            <a:off x="914400" y="2898648"/>
             <a:ext cx="7406640" cy="274320"/>
           </a:xfrm>
           <a:prstGeom prst="rect">
@@ -19239,6 +18931,45 @@
               <a:t>수락률 60%, NPS 40+, WAU 1000</a:t>
             </a:r>
             <a:endParaRPr lang="en-US" sz="1100" dirty="0"/>
+          </a:p>
+        </p:txBody>
+      </p:sp>
+      <p:sp>
+        <p:nvSpPr>
+          <p:cNvPr id="15" name="Text 13"/>
+          <p:cNvSpPr/>
+          <p:nvPr/>
+        </p:nvSpPr>
+        <p:spPr>
+          <a:xfrm>
+            <a:off x="640080" y="4320540"/>
+            <a:ext cx="7863840" cy="274320"/>
+          </a:xfrm>
+          <a:prstGeom prst="rect">
+            <a:avLst/>
+          </a:prstGeom>
+          <a:noFill/>
+          <a:ln/>
+        </p:spPr>
+        <p:txBody>
+          <a:bodyPr wrap="square" lIns="0" tIns="0" rIns="0" bIns="0" rtlCol="0" anchor="ctr"/>
+          <a:lstStyle/>
+          <a:p>
+            <a:pPr marL="0" indent="0" algn="l">
+              <a:buNone/>
+            </a:pPr>
+            <a:r>
+              <a:rPr lang="en-US" sz="1000" b="1" dirty="0">
+                <a:solidFill>
+                  <a:srgbClr val="FF6B35"/>
+                </a:solidFill>
+                <a:latin typeface="NanumGothic" pitchFamily="34" charset="0"/>
+                <a:ea typeface="NanumGothic" pitchFamily="34" charset="-122"/>
+                <a:cs typeface="NanumGothic" pitchFamily="34" charset="-120"/>
+              </a:rPr>
+              <a:t>원칙: 구체적 &gt; 추상적  |  숫자 &gt; 형용사  |  링크 &gt; 복사  (PRD 작성 5대 원칙)</a:t>
+            </a:r>
+            <a:endParaRPr lang="en-US" sz="1000" dirty="0"/>
           </a:p>
         </p:txBody>
       </p:sp>
@@ -19450,6 +19181,45 @@
           </a:p>
         </p:txBody>
       </p:sp>
+      <p:sp>
+        <p:nvSpPr>
+          <p:cNvPr id="6" name="Text 4"/>
+          <p:cNvSpPr/>
+          <p:nvPr/>
+        </p:nvSpPr>
+        <p:spPr>
+          <a:xfrm>
+            <a:off x="640080" y="4320540"/>
+            <a:ext cx="7863840" cy="274320"/>
+          </a:xfrm>
+          <a:prstGeom prst="rect">
+            <a:avLst/>
+          </a:prstGeom>
+          <a:noFill/>
+          <a:ln/>
+        </p:spPr>
+        <p:txBody>
+          <a:bodyPr wrap="square" lIns="0" tIns="0" rIns="0" bIns="0" rtlCol="0" anchor="ctr"/>
+          <a:lstStyle/>
+          <a:p>
+            <a:pPr marL="0" indent="0" algn="l">
+              <a:buNone/>
+            </a:pPr>
+            <a:r>
+              <a:rPr lang="en-US" sz="1000" i="1" dirty="0">
+                <a:solidFill>
+                  <a:srgbClr val="6B7280"/>
+                </a:solidFill>
+                <a:latin typeface="NanumGothic" pitchFamily="34" charset="0"/>
+                <a:ea typeface="NanumGothic" pitchFamily="34" charset="-122"/>
+                <a:cs typeface="NanumGothic" pitchFamily="34" charset="-120"/>
+              </a:rPr>
+              <a:t>💡 손 들기 유도:  "AI?  프로토타이핑?  데이터?"</a:t>
+            </a:r>
+            <a:endParaRPr lang="en-US" sz="1000" dirty="0"/>
+          </a:p>
+        </p:txBody>
+      </p:sp>
     </p:spTree>
   </p:cSld>
   <p:clrMapOvr>
@@ -19584,7 +19354,7 @@
         </p:nvSpPr>
         <p:spPr>
           <a:xfrm>
-            <a:off x="640080" y="1361784"/>
+            <a:off x="640080" y="1005840"/>
             <a:ext cx="7863840" cy="2377440"/>
           </a:xfrm>
           <a:prstGeom prst="rect">
@@ -19611,7 +19381,7 @@
         </p:nvSpPr>
         <p:spPr>
           <a:xfrm>
-            <a:off x="914400" y="1544664"/>
+            <a:off x="914400" y="1188720"/>
             <a:ext cx="7315200" cy="2011680"/>
           </a:xfrm>
           <a:prstGeom prst="rect">
@@ -19746,7 +19516,7 @@
         </p:nvSpPr>
         <p:spPr>
           <a:xfrm>
-            <a:off x="640080" y="3922104"/>
+            <a:off x="640080" y="3566160"/>
             <a:ext cx="7863840" cy="274320"/>
           </a:xfrm>
           <a:prstGeom prst="rect">
@@ -19912,14 +19682,14 @@
           <p:nvPr>
             <p:extLst>
               <p:ext uri="{D42A27DB-BD31-4B8C-83A1-F6EECF244321}">
-                <p14:modId xmlns:p14="http://schemas.microsoft.com/office/powerpoint/2010/main" val="1462157086"/>
+                <p14:modId xmlns:p14="http://schemas.microsoft.com/office/powerpoint/2010/main" val="1579011935"/>
               </p:ext>
             </p:extLst>
           </p:nvPr>
         </p:nvGraphicFramePr>
         <p:xfrm>
-          <a:off x="457200" y="1444325"/>
-          <a:ext cx="8229600" cy="2176272"/>
+          <a:off x="457200" y="1051560"/>
+          <a:ext cx="8229600" cy="914400"/>
         </p:xfrm>
         <a:graphic>
           <a:graphicData uri="http://schemas.openxmlformats.org/drawingml/2006/table">
@@ -20946,7 +20716,7 @@
         </p:nvSpPr>
         <p:spPr>
           <a:xfrm>
-            <a:off x="640080" y="1054326"/>
+            <a:off x="640080" y="1097280"/>
             <a:ext cx="7863840" cy="320040"/>
           </a:xfrm>
           <a:prstGeom prst="rect">
@@ -20988,7 +20758,7 @@
         </p:nvSpPr>
         <p:spPr>
           <a:xfrm>
-            <a:off x="640080" y="1597753"/>
+            <a:off x="640080" y="1051560"/>
             <a:ext cx="2514600" cy="2377440"/>
           </a:xfrm>
           <a:prstGeom prst="rect">
@@ -21015,7 +20785,7 @@
         </p:nvSpPr>
         <p:spPr>
           <a:xfrm>
-            <a:off x="777240" y="1689193"/>
+            <a:off x="777240" y="1143000"/>
             <a:ext cx="2240280" cy="320040"/>
           </a:xfrm>
           <a:prstGeom prst="rect">
@@ -21054,7 +20824,7 @@
         </p:nvSpPr>
         <p:spPr>
           <a:xfrm>
-            <a:off x="777240" y="2100673"/>
+            <a:off x="777240" y="1554480"/>
             <a:ext cx="2240280" cy="731520"/>
           </a:xfrm>
           <a:prstGeom prst="rect">
@@ -21116,7 +20886,7 @@
         </p:nvSpPr>
         <p:spPr>
           <a:xfrm>
-            <a:off x="777240" y="2923633"/>
+            <a:off x="777240" y="2377440"/>
             <a:ext cx="2240280" cy="18288"/>
           </a:xfrm>
           <a:prstGeom prst="rect">
@@ -21143,7 +20913,7 @@
         </p:nvSpPr>
         <p:spPr>
           <a:xfrm>
-            <a:off x="777240" y="3015073"/>
+            <a:off x="777240" y="2468880"/>
             <a:ext cx="2240280" cy="274320"/>
           </a:xfrm>
           <a:prstGeom prst="rect">
@@ -21182,7 +20952,7 @@
         </p:nvSpPr>
         <p:spPr>
           <a:xfrm>
-            <a:off x="3383280" y="1597753"/>
+            <a:off x="3383280" y="1051560"/>
             <a:ext cx="2514600" cy="2377440"/>
           </a:xfrm>
           <a:prstGeom prst="rect">
@@ -21209,7 +20979,7 @@
         </p:nvSpPr>
         <p:spPr>
           <a:xfrm>
-            <a:off x="3520440" y="1689193"/>
+            <a:off x="3520440" y="1143000"/>
             <a:ext cx="2240280" cy="320040"/>
           </a:xfrm>
           <a:prstGeom prst="rect">
@@ -21248,7 +21018,7 @@
         </p:nvSpPr>
         <p:spPr>
           <a:xfrm>
-            <a:off x="3520440" y="2100673"/>
+            <a:off x="3520440" y="1554480"/>
             <a:ext cx="2240280" cy="731520"/>
           </a:xfrm>
           <a:prstGeom prst="rect">
@@ -21310,7 +21080,7 @@
         </p:nvSpPr>
         <p:spPr>
           <a:xfrm>
-            <a:off x="3520440" y="2923633"/>
+            <a:off x="3520440" y="2377440"/>
             <a:ext cx="2240280" cy="18288"/>
           </a:xfrm>
           <a:prstGeom prst="rect">
@@ -21337,7 +21107,7 @@
         </p:nvSpPr>
         <p:spPr>
           <a:xfrm>
-            <a:off x="3520440" y="3015073"/>
+            <a:off x="3520440" y="2468880"/>
             <a:ext cx="2240280" cy="274320"/>
           </a:xfrm>
           <a:prstGeom prst="rect">
@@ -21376,7 +21146,7 @@
         </p:nvSpPr>
         <p:spPr>
           <a:xfrm>
-            <a:off x="6126480" y="1597753"/>
+            <a:off x="6126480" y="1051560"/>
             <a:ext cx="2514600" cy="2377440"/>
           </a:xfrm>
           <a:prstGeom prst="rect">
@@ -21403,7 +21173,7 @@
         </p:nvSpPr>
         <p:spPr>
           <a:xfrm>
-            <a:off x="6263640" y="1689193"/>
+            <a:off x="6263640" y="1143000"/>
             <a:ext cx="2240280" cy="320040"/>
           </a:xfrm>
           <a:prstGeom prst="rect">
@@ -21442,7 +21212,7 @@
         </p:nvSpPr>
         <p:spPr>
           <a:xfrm>
-            <a:off x="6263640" y="2100673"/>
+            <a:off x="6263640" y="1554480"/>
             <a:ext cx="2240280" cy="731520"/>
           </a:xfrm>
           <a:prstGeom prst="rect">
@@ -21504,7 +21274,7 @@
         </p:nvSpPr>
         <p:spPr>
           <a:xfrm>
-            <a:off x="6263640" y="2923633"/>
+            <a:off x="6263640" y="2377440"/>
             <a:ext cx="2240280" cy="18288"/>
           </a:xfrm>
           <a:prstGeom prst="rect">
@@ -21531,7 +21301,7 @@
         </p:nvSpPr>
         <p:spPr>
           <a:xfrm>
-            <a:off x="6263640" y="3015073"/>
+            <a:off x="6263640" y="2468880"/>
             <a:ext cx="2240280" cy="274320"/>
           </a:xfrm>
           <a:prstGeom prst="rect">
@@ -21612,6 +21382,948 @@
 <file path=ppt/slides/slide33.xml><?xml version="1.0" encoding="utf-8"?>
 <p:sld xmlns:a="http://schemas.openxmlformats.org/drawingml/2006/main" xmlns:r="http://schemas.openxmlformats.org/officeDocument/2006/relationships" xmlns:p="http://schemas.openxmlformats.org/presentationml/2006/main">
   <p:cSld name="Slide 33">
+    <p:bg>
+      <p:bgPr>
+        <a:solidFill>
+          <a:srgbClr val="FFFFFF"/>
+        </a:solidFill>
+        <a:effectLst/>
+      </p:bgPr>
+    </p:bg>
+    <p:spTree>
+      <p:nvGrpSpPr>
+        <p:cNvPr id="1" name=""/>
+        <p:cNvGrpSpPr/>
+        <p:nvPr/>
+      </p:nvGrpSpPr>
+      <p:grpSpPr>
+        <a:xfrm>
+          <a:off x="0" y="0"/>
+          <a:ext cx="0" cy="0"/>
+          <a:chOff x="0" y="0"/>
+          <a:chExt cx="0" cy="0"/>
+        </a:xfrm>
+      </p:grpSpPr>
+      <p:sp>
+        <p:nvSpPr>
+          <p:cNvPr id="2" name="Shape 0"/>
+          <p:cNvSpPr/>
+          <p:nvPr/>
+        </p:nvSpPr>
+        <p:spPr>
+          <a:xfrm>
+            <a:off x="0" y="0"/>
+            <a:ext cx="9144000" cy="457200"/>
+          </a:xfrm>
+          <a:prstGeom prst="rect">
+            <a:avLst/>
+          </a:prstGeom>
+          <a:solidFill>
+            <a:srgbClr val="111111"/>
+          </a:solidFill>
+          <a:ln/>
+        </p:spPr>
+        <p:txBody>
+          <a:bodyPr/>
+          <a:lstStyle/>
+          <a:p>
+            <a:endParaRPr lang="ko-KR" altLang="en-US"/>
+          </a:p>
+        </p:txBody>
+      </p:sp>
+      <p:sp>
+        <p:nvSpPr>
+          <p:cNvPr id="3" name="Shape 1"/>
+          <p:cNvSpPr/>
+          <p:nvPr/>
+        </p:nvSpPr>
+        <p:spPr>
+          <a:xfrm>
+            <a:off x="0" y="4686300"/>
+            <a:ext cx="9144000" cy="457200"/>
+          </a:xfrm>
+          <a:prstGeom prst="rect">
+            <a:avLst/>
+          </a:prstGeom>
+          <a:solidFill>
+            <a:srgbClr val="111111"/>
+          </a:solidFill>
+          <a:ln/>
+        </p:spPr>
+        <p:txBody>
+          <a:bodyPr/>
+          <a:lstStyle/>
+          <a:p>
+            <a:endParaRPr lang="ko-KR" altLang="en-US"/>
+          </a:p>
+        </p:txBody>
+      </p:sp>
+      <p:sp>
+        <p:nvSpPr>
+          <p:cNvPr id="4" name="Text 2"/>
+          <p:cNvSpPr/>
+          <p:nvPr/>
+        </p:nvSpPr>
+        <p:spPr>
+          <a:xfrm>
+            <a:off x="640080" y="566928"/>
+            <a:ext cx="7863840" cy="502920"/>
+          </a:xfrm>
+          <a:prstGeom prst="rect">
+            <a:avLst/>
+          </a:prstGeom>
+          <a:noFill/>
+          <a:ln/>
+        </p:spPr>
+        <p:txBody>
+          <a:bodyPr wrap="square" lIns="0" tIns="0" rIns="0" bIns="0" rtlCol="0" anchor="ctr"/>
+          <a:lstStyle/>
+          <a:p>
+            <a:pPr marL="0" indent="0">
+              <a:buNone/>
+            </a:pPr>
+            <a:r>
+              <a:rPr lang="en-US" sz="2600" b="1" dirty="0">
+                <a:solidFill>
+                  <a:srgbClr val="111111"/>
+                </a:solidFill>
+                <a:latin typeface="NanumGothicExtraBold" pitchFamily="34" charset="0"/>
+                <a:ea typeface="NanumGothicExtraBold" pitchFamily="34" charset="-122"/>
+                <a:cs typeface="NanumGothicExtraBold" pitchFamily="34" charset="-120"/>
+              </a:rPr>
+              <a:t>Next Level: AI 자동화로 생산성 높이기</a:t>
+            </a:r>
+            <a:endParaRPr lang="en-US" sz="2600" dirty="0"/>
+          </a:p>
+        </p:txBody>
+      </p:sp>
+      <p:sp>
+        <p:nvSpPr>
+          <p:cNvPr id="5" name="Text 3"/>
+          <p:cNvSpPr/>
+          <p:nvPr/>
+        </p:nvSpPr>
+        <p:spPr>
+          <a:xfrm>
+            <a:off x="640080" y="1468265"/>
+            <a:ext cx="7863840" cy="320040"/>
+          </a:xfrm>
+          <a:prstGeom prst="rect">
+            <a:avLst/>
+          </a:prstGeom>
+          <a:noFill/>
+          <a:ln/>
+        </p:spPr>
+        <p:txBody>
+          <a:bodyPr wrap="square" lIns="0" tIns="0" rIns="0" bIns="0" rtlCol="0" anchor="ctr"/>
+          <a:lstStyle/>
+          <a:p>
+            <a:pPr marL="0" indent="0">
+              <a:lnSpc>
+                <a:spcPct val="130000"/>
+              </a:lnSpc>
+              <a:buNone/>
+            </a:pPr>
+            <a:r>
+              <a:rPr lang="en-US" sz="1200" dirty="0">
+                <a:solidFill>
+                  <a:srgbClr val="6B7280"/>
+                </a:solidFill>
+                <a:latin typeface="NanumGothic" pitchFamily="34" charset="0"/>
+                <a:ea typeface="NanumGothic" pitchFamily="34" charset="-122"/>
+                <a:cs typeface="NanumGothic" pitchFamily="34" charset="-120"/>
+              </a:rPr>
+              <a:t>Claude는 요청하면 다 해주지만, 자주 하는 작업을 자동화하면 속도가 달라집니다</a:t>
+            </a:r>
+            <a:endParaRPr lang="en-US" sz="1200" dirty="0"/>
+          </a:p>
+        </p:txBody>
+      </p:sp>
+      <p:sp>
+        <p:nvSpPr>
+          <p:cNvPr id="6" name="Shape 4"/>
+          <p:cNvSpPr/>
+          <p:nvPr/>
+        </p:nvSpPr>
+        <p:spPr>
+          <a:xfrm>
+            <a:off x="640080" y="1376825"/>
+            <a:ext cx="7863840" cy="530352"/>
+          </a:xfrm>
+          <a:prstGeom prst="rect">
+            <a:avLst/>
+          </a:prstGeom>
+          <a:solidFill>
+            <a:srgbClr val="F5F5F5"/>
+          </a:solidFill>
+          <a:ln/>
+        </p:spPr>
+        <p:txBody>
+          <a:bodyPr/>
+          <a:lstStyle/>
+          <a:p>
+            <a:endParaRPr lang="ko-KR" altLang="en-US"/>
+          </a:p>
+        </p:txBody>
+      </p:sp>
+      <p:sp>
+        <p:nvSpPr>
+          <p:cNvPr id="7" name="Shape 5"/>
+          <p:cNvSpPr/>
+          <p:nvPr/>
+        </p:nvSpPr>
+        <p:spPr>
+          <a:xfrm>
+            <a:off x="713232" y="1449977"/>
+            <a:ext cx="457200" cy="384048"/>
+          </a:xfrm>
+          <a:prstGeom prst="rect">
+            <a:avLst/>
+          </a:prstGeom>
+          <a:solidFill>
+            <a:srgbClr val="E5E7EB"/>
+          </a:solidFill>
+          <a:ln/>
+        </p:spPr>
+        <p:txBody>
+          <a:bodyPr/>
+          <a:lstStyle/>
+          <a:p>
+            <a:endParaRPr lang="ko-KR" altLang="en-US"/>
+          </a:p>
+        </p:txBody>
+      </p:sp>
+      <p:sp>
+        <p:nvSpPr>
+          <p:cNvPr id="8" name="Text 6"/>
+          <p:cNvSpPr/>
+          <p:nvPr/>
+        </p:nvSpPr>
+        <p:spPr>
+          <a:xfrm>
+            <a:off x="713232" y="1449977"/>
+            <a:ext cx="457200" cy="384048"/>
+          </a:xfrm>
+          <a:prstGeom prst="rect">
+            <a:avLst/>
+          </a:prstGeom>
+          <a:noFill/>
+          <a:ln/>
+        </p:spPr>
+        <p:txBody>
+          <a:bodyPr wrap="square" lIns="0" tIns="0" rIns="0" bIns="0" rtlCol="0" anchor="ctr"/>
+          <a:lstStyle/>
+          <a:p>
+            <a:pPr marL="0" indent="0" algn="ctr">
+              <a:buNone/>
+            </a:pPr>
+            <a:r>
+              <a:rPr lang="en-US" sz="1000" dirty="0">
+                <a:solidFill>
+                  <a:srgbClr val="111111"/>
+                </a:solidFill>
+                <a:latin typeface="NanumGothicExtraBold" pitchFamily="34" charset="0"/>
+                <a:ea typeface="NanumGothicExtraBold" pitchFamily="34" charset="-122"/>
+                <a:cs typeface="NanumGothicExtraBold" pitchFamily="34" charset="-120"/>
+              </a:rPr>
+              <a:t>Lv.1</a:t>
+            </a:r>
+            <a:endParaRPr lang="en-US" sz="1000" dirty="0"/>
+          </a:p>
+        </p:txBody>
+      </p:sp>
+      <p:sp>
+        <p:nvSpPr>
+          <p:cNvPr id="9" name="Text 7"/>
+          <p:cNvSpPr/>
+          <p:nvPr/>
+        </p:nvSpPr>
+        <p:spPr>
+          <a:xfrm>
+            <a:off x="1371600" y="1376825"/>
+            <a:ext cx="2103120" cy="530352"/>
+          </a:xfrm>
+          <a:prstGeom prst="rect">
+            <a:avLst/>
+          </a:prstGeom>
+          <a:noFill/>
+          <a:ln/>
+        </p:spPr>
+        <p:txBody>
+          <a:bodyPr wrap="square" lIns="0" tIns="0" rIns="0" bIns="0" rtlCol="0" anchor="ctr"/>
+          <a:lstStyle/>
+          <a:p>
+            <a:pPr marL="0" indent="0">
+              <a:buNone/>
+            </a:pPr>
+            <a:r>
+              <a:rPr lang="en-US" sz="1300" dirty="0">
+                <a:solidFill>
+                  <a:srgbClr val="111111"/>
+                </a:solidFill>
+                <a:latin typeface="NanumGothicExtraBold" pitchFamily="34" charset="0"/>
+                <a:ea typeface="NanumGothicExtraBold" pitchFamily="34" charset="-122"/>
+                <a:cs typeface="NanumGothicExtraBold" pitchFamily="34" charset="-120"/>
+              </a:rPr>
+              <a:t>대화형 사용</a:t>
+            </a:r>
+            <a:endParaRPr lang="en-US" sz="1300" dirty="0"/>
+          </a:p>
+        </p:txBody>
+      </p:sp>
+      <p:sp>
+        <p:nvSpPr>
+          <p:cNvPr id="10" name="Text 8"/>
+          <p:cNvSpPr/>
+          <p:nvPr/>
+        </p:nvSpPr>
+        <p:spPr>
+          <a:xfrm>
+            <a:off x="3566160" y="1376825"/>
+            <a:ext cx="4846320" cy="530352"/>
+          </a:xfrm>
+          <a:prstGeom prst="rect">
+            <a:avLst/>
+          </a:prstGeom>
+          <a:noFill/>
+          <a:ln/>
+        </p:spPr>
+        <p:txBody>
+          <a:bodyPr wrap="square" lIns="0" tIns="0" rIns="0" bIns="0" rtlCol="0" anchor="ctr"/>
+          <a:lstStyle/>
+          <a:p>
+            <a:pPr marL="0" indent="0">
+              <a:lnSpc>
+                <a:spcPct val="125000"/>
+              </a:lnSpc>
+              <a:buNone/>
+            </a:pPr>
+            <a:r>
+              <a:rPr lang="en-US" sz="1000" dirty="0">
+                <a:solidFill>
+                  <a:srgbClr val="6B7280"/>
+                </a:solidFill>
+                <a:latin typeface="NanumGothic" pitchFamily="34" charset="0"/>
+                <a:ea typeface="NanumGothic" pitchFamily="34" charset="-122"/>
+                <a:cs typeface="NanumGothic" pitchFamily="34" charset="-120"/>
+              </a:rPr>
+              <a:t>Claude에게 하나씩 요청  →  PRD 생성, 프로토타입 제작</a:t>
+            </a:r>
+            <a:endParaRPr lang="en-US" sz="1000" dirty="0"/>
+          </a:p>
+        </p:txBody>
+      </p:sp>
+      <p:sp>
+        <p:nvSpPr>
+          <p:cNvPr id="11" name="Text 9"/>
+          <p:cNvSpPr/>
+          <p:nvPr/>
+        </p:nvSpPr>
+        <p:spPr>
+          <a:xfrm>
+            <a:off x="7406640" y="1422545"/>
+            <a:ext cx="1005840" cy="228600"/>
+          </a:xfrm>
+          <a:prstGeom prst="rect">
+            <a:avLst/>
+          </a:prstGeom>
+          <a:noFill/>
+          <a:ln/>
+        </p:spPr>
+        <p:txBody>
+          <a:bodyPr wrap="square" lIns="0" tIns="0" rIns="0" bIns="0" rtlCol="0" anchor="ctr"/>
+          <a:lstStyle/>
+          <a:p>
+            <a:pPr marL="0" indent="0" algn="r">
+              <a:buNone/>
+            </a:pPr>
+            <a:r>
+              <a:rPr lang="en-US" sz="900" dirty="0">
+                <a:solidFill>
+                  <a:srgbClr val="FF6B35"/>
+                </a:solidFill>
+                <a:latin typeface="NanumGothic Bold" pitchFamily="34" charset="0"/>
+                <a:ea typeface="NanumGothic Bold" pitchFamily="34" charset="-122"/>
+                <a:cs typeface="NanumGothic Bold" pitchFamily="34" charset="-120"/>
+              </a:rPr>
+              <a:t>← 지금 여기</a:t>
+            </a:r>
+            <a:endParaRPr lang="en-US" sz="900" dirty="0"/>
+          </a:p>
+        </p:txBody>
+      </p:sp>
+      <p:sp>
+        <p:nvSpPr>
+          <p:cNvPr id="12" name="Shape 10"/>
+          <p:cNvSpPr/>
+          <p:nvPr/>
+        </p:nvSpPr>
+        <p:spPr>
+          <a:xfrm>
+            <a:off x="640080" y="2016905"/>
+            <a:ext cx="7863840" cy="530352"/>
+          </a:xfrm>
+          <a:prstGeom prst="rect">
+            <a:avLst/>
+          </a:prstGeom>
+          <a:solidFill>
+            <a:srgbClr val="F5F5F5"/>
+          </a:solidFill>
+          <a:ln/>
+        </p:spPr>
+        <p:txBody>
+          <a:bodyPr/>
+          <a:lstStyle/>
+          <a:p>
+            <a:endParaRPr lang="ko-KR" altLang="en-US"/>
+          </a:p>
+        </p:txBody>
+      </p:sp>
+      <p:sp>
+        <p:nvSpPr>
+          <p:cNvPr id="13" name="Shape 11"/>
+          <p:cNvSpPr/>
+          <p:nvPr/>
+        </p:nvSpPr>
+        <p:spPr>
+          <a:xfrm>
+            <a:off x="713232" y="2090057"/>
+            <a:ext cx="457200" cy="384048"/>
+          </a:xfrm>
+          <a:prstGeom prst="rect">
+            <a:avLst/>
+          </a:prstGeom>
+          <a:solidFill>
+            <a:srgbClr val="2A2A2A"/>
+          </a:solidFill>
+          <a:ln/>
+        </p:spPr>
+        <p:txBody>
+          <a:bodyPr/>
+          <a:lstStyle/>
+          <a:p>
+            <a:endParaRPr lang="ko-KR" altLang="en-US"/>
+          </a:p>
+        </p:txBody>
+      </p:sp>
+      <p:sp>
+        <p:nvSpPr>
+          <p:cNvPr id="14" name="Text 12"/>
+          <p:cNvSpPr/>
+          <p:nvPr/>
+        </p:nvSpPr>
+        <p:spPr>
+          <a:xfrm>
+            <a:off x="713232" y="2090057"/>
+            <a:ext cx="457200" cy="384048"/>
+          </a:xfrm>
+          <a:prstGeom prst="rect">
+            <a:avLst/>
+          </a:prstGeom>
+          <a:noFill/>
+          <a:ln/>
+        </p:spPr>
+        <p:txBody>
+          <a:bodyPr wrap="square" lIns="0" tIns="0" rIns="0" bIns="0" rtlCol="0" anchor="ctr"/>
+          <a:lstStyle/>
+          <a:p>
+            <a:pPr marL="0" indent="0" algn="ctr">
+              <a:buNone/>
+            </a:pPr>
+            <a:r>
+              <a:rPr lang="en-US" sz="1000" dirty="0">
+                <a:solidFill>
+                  <a:srgbClr val="FFFFFF"/>
+                </a:solidFill>
+                <a:latin typeface="NanumGothicExtraBold" pitchFamily="34" charset="0"/>
+                <a:ea typeface="NanumGothicExtraBold" pitchFamily="34" charset="-122"/>
+                <a:cs typeface="NanumGothicExtraBold" pitchFamily="34" charset="-120"/>
+              </a:rPr>
+              <a:t>Lv.2</a:t>
+            </a:r>
+            <a:endParaRPr lang="en-US" sz="1000" dirty="0"/>
+          </a:p>
+        </p:txBody>
+      </p:sp>
+      <p:sp>
+        <p:nvSpPr>
+          <p:cNvPr id="15" name="Text 13"/>
+          <p:cNvSpPr/>
+          <p:nvPr/>
+        </p:nvSpPr>
+        <p:spPr>
+          <a:xfrm>
+            <a:off x="1371600" y="2016905"/>
+            <a:ext cx="2103120" cy="530352"/>
+          </a:xfrm>
+          <a:prstGeom prst="rect">
+            <a:avLst/>
+          </a:prstGeom>
+          <a:noFill/>
+          <a:ln/>
+        </p:spPr>
+        <p:txBody>
+          <a:bodyPr wrap="square" lIns="0" tIns="0" rIns="0" bIns="0" rtlCol="0" anchor="ctr"/>
+          <a:lstStyle/>
+          <a:p>
+            <a:pPr marL="0" indent="0">
+              <a:buNone/>
+            </a:pPr>
+            <a:r>
+              <a:rPr lang="en-US" sz="1300" dirty="0">
+                <a:solidFill>
+                  <a:srgbClr val="111111"/>
+                </a:solidFill>
+                <a:latin typeface="NanumGothicExtraBold" pitchFamily="34" charset="0"/>
+                <a:ea typeface="NanumGothicExtraBold" pitchFamily="34" charset="-122"/>
+                <a:cs typeface="NanumGothicExtraBold" pitchFamily="34" charset="-120"/>
+              </a:rPr>
+              <a:t>MCP + Skill 세팅</a:t>
+            </a:r>
+            <a:endParaRPr lang="en-US" sz="1300" dirty="0"/>
+          </a:p>
+        </p:txBody>
+      </p:sp>
+      <p:sp>
+        <p:nvSpPr>
+          <p:cNvPr id="16" name="Text 14"/>
+          <p:cNvSpPr/>
+          <p:nvPr/>
+        </p:nvSpPr>
+        <p:spPr>
+          <a:xfrm>
+            <a:off x="3566160" y="2016905"/>
+            <a:ext cx="4846320" cy="530352"/>
+          </a:xfrm>
+          <a:prstGeom prst="rect">
+            <a:avLst/>
+          </a:prstGeom>
+          <a:noFill/>
+          <a:ln/>
+        </p:spPr>
+        <p:txBody>
+          <a:bodyPr wrap="square" lIns="0" tIns="0" rIns="0" bIns="0" rtlCol="0" anchor="ctr"/>
+          <a:lstStyle/>
+          <a:p>
+            <a:pPr marL="0" indent="0">
+              <a:lnSpc>
+                <a:spcPct val="125000"/>
+              </a:lnSpc>
+              <a:buNone/>
+            </a:pPr>
+            <a:r>
+              <a:rPr lang="en-US" sz="1000" dirty="0">
+                <a:solidFill>
+                  <a:srgbClr val="6B7280"/>
+                </a:solidFill>
+                <a:latin typeface="NanumGothic" pitchFamily="34" charset="0"/>
+                <a:ea typeface="NanumGothic" pitchFamily="34" charset="-122"/>
+                <a:cs typeface="NanumGothic" pitchFamily="34" charset="-120"/>
+              </a:rPr>
+              <a:t>MCP: Jira·Slack 등 외부 서비스 연결  |  Skill: PM별 자주 쓰는 명령 미리 등록</a:t>
+            </a:r>
+            <a:endParaRPr lang="en-US" sz="1000" dirty="0"/>
+          </a:p>
+        </p:txBody>
+      </p:sp>
+      <p:sp>
+        <p:nvSpPr>
+          <p:cNvPr id="17" name="Shape 15"/>
+          <p:cNvSpPr/>
+          <p:nvPr/>
+        </p:nvSpPr>
+        <p:spPr>
+          <a:xfrm>
+            <a:off x="640080" y="2656985"/>
+            <a:ext cx="7863840" cy="530352"/>
+          </a:xfrm>
+          <a:prstGeom prst="rect">
+            <a:avLst/>
+          </a:prstGeom>
+          <a:solidFill>
+            <a:srgbClr val="F5F5F5"/>
+          </a:solidFill>
+          <a:ln/>
+        </p:spPr>
+        <p:txBody>
+          <a:bodyPr/>
+          <a:lstStyle/>
+          <a:p>
+            <a:endParaRPr lang="ko-KR" altLang="en-US"/>
+          </a:p>
+        </p:txBody>
+      </p:sp>
+      <p:sp>
+        <p:nvSpPr>
+          <p:cNvPr id="18" name="Shape 16"/>
+          <p:cNvSpPr/>
+          <p:nvPr/>
+        </p:nvSpPr>
+        <p:spPr>
+          <a:xfrm>
+            <a:off x="713232" y="2730137"/>
+            <a:ext cx="457200" cy="384048"/>
+          </a:xfrm>
+          <a:prstGeom prst="rect">
+            <a:avLst/>
+          </a:prstGeom>
+          <a:solidFill>
+            <a:srgbClr val="2A2A2A"/>
+          </a:solidFill>
+          <a:ln/>
+        </p:spPr>
+        <p:txBody>
+          <a:bodyPr/>
+          <a:lstStyle/>
+          <a:p>
+            <a:endParaRPr lang="ko-KR" altLang="en-US"/>
+          </a:p>
+        </p:txBody>
+      </p:sp>
+      <p:sp>
+        <p:nvSpPr>
+          <p:cNvPr id="19" name="Text 17"/>
+          <p:cNvSpPr/>
+          <p:nvPr/>
+        </p:nvSpPr>
+        <p:spPr>
+          <a:xfrm>
+            <a:off x="713232" y="2730137"/>
+            <a:ext cx="457200" cy="384048"/>
+          </a:xfrm>
+          <a:prstGeom prst="rect">
+            <a:avLst/>
+          </a:prstGeom>
+          <a:noFill/>
+          <a:ln/>
+        </p:spPr>
+        <p:txBody>
+          <a:bodyPr wrap="square" lIns="0" tIns="0" rIns="0" bIns="0" rtlCol="0" anchor="ctr"/>
+          <a:lstStyle/>
+          <a:p>
+            <a:pPr marL="0" indent="0" algn="ctr">
+              <a:buNone/>
+            </a:pPr>
+            <a:r>
+              <a:rPr lang="en-US" sz="1000" dirty="0">
+                <a:solidFill>
+                  <a:srgbClr val="FFFFFF"/>
+                </a:solidFill>
+                <a:latin typeface="NanumGothicExtraBold" pitchFamily="34" charset="0"/>
+                <a:ea typeface="NanumGothicExtraBold" pitchFamily="34" charset="-122"/>
+                <a:cs typeface="NanumGothicExtraBold" pitchFamily="34" charset="-120"/>
+              </a:rPr>
+              <a:t>Lv.3</a:t>
+            </a:r>
+            <a:endParaRPr lang="en-US" sz="1000" dirty="0"/>
+          </a:p>
+        </p:txBody>
+      </p:sp>
+      <p:sp>
+        <p:nvSpPr>
+          <p:cNvPr id="20" name="Text 18"/>
+          <p:cNvSpPr/>
+          <p:nvPr/>
+        </p:nvSpPr>
+        <p:spPr>
+          <a:xfrm>
+            <a:off x="1371600" y="2656985"/>
+            <a:ext cx="2103120" cy="530352"/>
+          </a:xfrm>
+          <a:prstGeom prst="rect">
+            <a:avLst/>
+          </a:prstGeom>
+          <a:noFill/>
+          <a:ln/>
+        </p:spPr>
+        <p:txBody>
+          <a:bodyPr wrap="square" lIns="0" tIns="0" rIns="0" bIns="0" rtlCol="0" anchor="ctr"/>
+          <a:lstStyle/>
+          <a:p>
+            <a:pPr marL="0" indent="0">
+              <a:buNone/>
+            </a:pPr>
+            <a:r>
+              <a:rPr lang="en-US" sz="1300" dirty="0">
+                <a:solidFill>
+                  <a:srgbClr val="111111"/>
+                </a:solidFill>
+                <a:latin typeface="NanumGothicExtraBold" pitchFamily="34" charset="0"/>
+                <a:ea typeface="NanumGothicExtraBold" pitchFamily="34" charset="-122"/>
+                <a:cs typeface="NanumGothicExtraBold" pitchFamily="34" charset="-120"/>
+              </a:rPr>
+              <a:t>Agent + Plugin 구성</a:t>
+            </a:r>
+            <a:endParaRPr lang="en-US" sz="1300" dirty="0"/>
+          </a:p>
+        </p:txBody>
+      </p:sp>
+      <p:sp>
+        <p:nvSpPr>
+          <p:cNvPr id="21" name="Text 19"/>
+          <p:cNvSpPr/>
+          <p:nvPr/>
+        </p:nvSpPr>
+        <p:spPr>
+          <a:xfrm>
+            <a:off x="3566160" y="2656985"/>
+            <a:ext cx="4846320" cy="530352"/>
+          </a:xfrm>
+          <a:prstGeom prst="rect">
+            <a:avLst/>
+          </a:prstGeom>
+          <a:noFill/>
+          <a:ln/>
+        </p:spPr>
+        <p:txBody>
+          <a:bodyPr wrap="square" lIns="0" tIns="0" rIns="0" bIns="0" rtlCol="0" anchor="ctr"/>
+          <a:lstStyle/>
+          <a:p>
+            <a:pPr marL="0" indent="0">
+              <a:lnSpc>
+                <a:spcPct val="125000"/>
+              </a:lnSpc>
+              <a:buNone/>
+            </a:pPr>
+            <a:r>
+              <a:rPr lang="en-US" sz="1000" dirty="0">
+                <a:solidFill>
+                  <a:srgbClr val="6B7280"/>
+                </a:solidFill>
+                <a:latin typeface="NanumGothic" pitchFamily="34" charset="0"/>
+                <a:ea typeface="NanumGothic" pitchFamily="34" charset="-122"/>
+                <a:cs typeface="NanumGothic" pitchFamily="34" charset="-120"/>
+              </a:rPr>
+              <a:t>Agent: 복잡한 작업을 자동 수행하는 AI 비서  |  Plugin: MCP+Skill을 묶어 원클릭 실행</a:t>
+            </a:r>
+            <a:endParaRPr lang="en-US" sz="1000" dirty="0"/>
+          </a:p>
+        </p:txBody>
+      </p:sp>
+      <p:sp>
+        <p:nvSpPr>
+          <p:cNvPr id="22" name="Shape 20"/>
+          <p:cNvSpPr/>
+          <p:nvPr/>
+        </p:nvSpPr>
+        <p:spPr>
+          <a:xfrm>
+            <a:off x="640080" y="3297065"/>
+            <a:ext cx="7863840" cy="530352"/>
+          </a:xfrm>
+          <a:prstGeom prst="rect">
+            <a:avLst/>
+          </a:prstGeom>
+          <a:solidFill>
+            <a:srgbClr val="111111"/>
+          </a:solidFill>
+          <a:ln/>
+        </p:spPr>
+        <p:txBody>
+          <a:bodyPr/>
+          <a:lstStyle/>
+          <a:p>
+            <a:endParaRPr lang="ko-KR" altLang="en-US"/>
+          </a:p>
+        </p:txBody>
+      </p:sp>
+      <p:sp>
+        <p:nvSpPr>
+          <p:cNvPr id="23" name="Shape 21"/>
+          <p:cNvSpPr/>
+          <p:nvPr/>
+        </p:nvSpPr>
+        <p:spPr>
+          <a:xfrm>
+            <a:off x="713232" y="3370217"/>
+            <a:ext cx="457200" cy="384048"/>
+          </a:xfrm>
+          <a:prstGeom prst="rect">
+            <a:avLst/>
+          </a:prstGeom>
+          <a:solidFill>
+            <a:srgbClr val="FF6B35"/>
+          </a:solidFill>
+          <a:ln/>
+        </p:spPr>
+        <p:txBody>
+          <a:bodyPr/>
+          <a:lstStyle/>
+          <a:p>
+            <a:endParaRPr lang="ko-KR" altLang="en-US"/>
+          </a:p>
+        </p:txBody>
+      </p:sp>
+      <p:sp>
+        <p:nvSpPr>
+          <p:cNvPr id="24" name="Text 22"/>
+          <p:cNvSpPr/>
+          <p:nvPr/>
+        </p:nvSpPr>
+        <p:spPr>
+          <a:xfrm>
+            <a:off x="713232" y="3370217"/>
+            <a:ext cx="457200" cy="384048"/>
+          </a:xfrm>
+          <a:prstGeom prst="rect">
+            <a:avLst/>
+          </a:prstGeom>
+          <a:noFill/>
+          <a:ln/>
+        </p:spPr>
+        <p:txBody>
+          <a:bodyPr wrap="square" lIns="0" tIns="0" rIns="0" bIns="0" rtlCol="0" anchor="ctr"/>
+          <a:lstStyle/>
+          <a:p>
+            <a:pPr marL="0" indent="0" algn="ctr">
+              <a:buNone/>
+            </a:pPr>
+            <a:r>
+              <a:rPr lang="en-US" sz="1000" dirty="0">
+                <a:solidFill>
+                  <a:srgbClr val="FFFFFF"/>
+                </a:solidFill>
+                <a:latin typeface="NanumGothicExtraBold" pitchFamily="34" charset="0"/>
+                <a:ea typeface="NanumGothicExtraBold" pitchFamily="34" charset="-122"/>
+                <a:cs typeface="NanumGothicExtraBold" pitchFamily="34" charset="-120"/>
+              </a:rPr>
+              <a:t>Lv.4</a:t>
+            </a:r>
+            <a:endParaRPr lang="en-US" sz="1000" dirty="0"/>
+          </a:p>
+        </p:txBody>
+      </p:sp>
+      <p:sp>
+        <p:nvSpPr>
+          <p:cNvPr id="25" name="Text 23"/>
+          <p:cNvSpPr/>
+          <p:nvPr/>
+        </p:nvSpPr>
+        <p:spPr>
+          <a:xfrm>
+            <a:off x="1371600" y="3297065"/>
+            <a:ext cx="2103120" cy="530352"/>
+          </a:xfrm>
+          <a:prstGeom prst="rect">
+            <a:avLst/>
+          </a:prstGeom>
+          <a:noFill/>
+          <a:ln/>
+        </p:spPr>
+        <p:txBody>
+          <a:bodyPr wrap="square" lIns="0" tIns="0" rIns="0" bIns="0" rtlCol="0" anchor="ctr"/>
+          <a:lstStyle/>
+          <a:p>
+            <a:pPr marL="0" indent="0">
+              <a:buNone/>
+            </a:pPr>
+            <a:r>
+              <a:rPr lang="en-US" sz="1300" dirty="0">
+                <a:solidFill>
+                  <a:srgbClr val="FFFFFF"/>
+                </a:solidFill>
+                <a:latin typeface="NanumGothicExtraBold" pitchFamily="34" charset="0"/>
+                <a:ea typeface="NanumGothicExtraBold" pitchFamily="34" charset="-122"/>
+                <a:cs typeface="NanumGothicExtraBold" pitchFamily="34" charset="-120"/>
+              </a:rPr>
+              <a:t>PM 조직 통합 자동화</a:t>
+            </a:r>
+            <a:endParaRPr lang="en-US" sz="1300" dirty="0"/>
+          </a:p>
+        </p:txBody>
+      </p:sp>
+      <p:sp>
+        <p:nvSpPr>
+          <p:cNvPr id="26" name="Text 24"/>
+          <p:cNvSpPr/>
+          <p:nvPr/>
+        </p:nvSpPr>
+        <p:spPr>
+          <a:xfrm>
+            <a:off x="3566160" y="3297065"/>
+            <a:ext cx="4846320" cy="530352"/>
+          </a:xfrm>
+          <a:prstGeom prst="rect">
+            <a:avLst/>
+          </a:prstGeom>
+          <a:noFill/>
+          <a:ln/>
+        </p:spPr>
+        <p:txBody>
+          <a:bodyPr wrap="square" lIns="0" tIns="0" rIns="0" bIns="0" rtlCol="0" anchor="ctr"/>
+          <a:lstStyle/>
+          <a:p>
+            <a:pPr marL="0" indent="0">
+              <a:lnSpc>
+                <a:spcPct val="125000"/>
+              </a:lnSpc>
+              <a:buNone/>
+            </a:pPr>
+            <a:r>
+              <a:rPr lang="en-US" sz="1000" dirty="0">
+                <a:solidFill>
+                  <a:srgbClr val="6B7280"/>
+                </a:solidFill>
+                <a:latin typeface="NanumGothic" pitchFamily="34" charset="0"/>
+                <a:ea typeface="NanumGothic" pitchFamily="34" charset="-122"/>
+                <a:cs typeface="NanumGothic" pitchFamily="34" charset="-120"/>
+              </a:rPr>
+              <a:t>팀 공통 Skill·Agent·Plugin을 표준화  →  온보딩 1일 내 세팅 완료</a:t>
+            </a:r>
+            <a:endParaRPr lang="en-US" sz="1000" dirty="0"/>
+          </a:p>
+        </p:txBody>
+      </p:sp>
+      <p:sp>
+        <p:nvSpPr>
+          <p:cNvPr id="27" name="Text 25"/>
+          <p:cNvSpPr/>
+          <p:nvPr/>
+        </p:nvSpPr>
+        <p:spPr>
+          <a:xfrm>
+            <a:off x="640080" y="4320540"/>
+            <a:ext cx="7863840" cy="274320"/>
+          </a:xfrm>
+          <a:prstGeom prst="rect">
+            <a:avLst/>
+          </a:prstGeom>
+          <a:noFill/>
+          <a:ln/>
+        </p:spPr>
+        <p:txBody>
+          <a:bodyPr wrap="square" lIns="0" tIns="0" rIns="0" bIns="0" rtlCol="0" anchor="ctr"/>
+          <a:lstStyle/>
+          <a:p>
+            <a:pPr marL="0" indent="0" algn="l">
+              <a:buNone/>
+            </a:pPr>
+            <a:r>
+              <a:rPr lang="en-US" sz="1000" b="1" dirty="0">
+                <a:solidFill>
+                  <a:srgbClr val="FF6B35"/>
+                </a:solidFill>
+                <a:latin typeface="NanumGothic" pitchFamily="34" charset="0"/>
+                <a:ea typeface="NanumGothic" pitchFamily="34" charset="-122"/>
+                <a:cs typeface="NanumGothic" pitchFamily="34" charset="-120"/>
+              </a:rPr>
+              <a:t>자동화는 한 번에 하는 게 아닙니다. 반복되는 작업부터 하나씩 — 그게 PM의 생산성입니다.</a:t>
+            </a:r>
+            <a:endParaRPr lang="en-US" sz="1000" dirty="0"/>
+          </a:p>
+        </p:txBody>
+      </p:sp>
+    </p:spTree>
+  </p:cSld>
+  <p:clrMapOvr>
+    <a:masterClrMapping/>
+  </p:clrMapOvr>
+</p:sld>
+</file>
+
+<file path=ppt/slides/slide34.xml><?xml version="1.0" encoding="utf-8"?>
+<p:sld xmlns:a="http://schemas.openxmlformats.org/drawingml/2006/main" xmlns:r="http://schemas.openxmlformats.org/officeDocument/2006/relationships" xmlns:p="http://schemas.openxmlformats.org/presentationml/2006/main">
+  <p:cSld name="Slide 34">
     <p:bg>
       <p:bgPr>
         <a:solidFill>
@@ -22123,51 +22835,7 @@
                 <a:ea typeface="NanumGothic" pitchFamily="34" charset="-122"/>
                 <a:cs typeface="NanumGothic" pitchFamily="34" charset="-120"/>
               </a:rPr>
-              <a:t>AI 시대에도 변하지 않는 </a:t>
-            </a:r>
-            <a:r>
-              <a:rPr lang="en-US" sz="1300" dirty="0" err="1">
-                <a:solidFill>
-                  <a:srgbClr val="6B7280"/>
-                </a:solidFill>
-                <a:latin typeface="NanumGothic" pitchFamily="34" charset="0"/>
-                <a:ea typeface="NanumGothic" pitchFamily="34" charset="-122"/>
-                <a:cs typeface="NanumGothic" pitchFamily="34" charset="-120"/>
-              </a:rPr>
-              <a:t>PM의</a:t>
-            </a:r>
-            <a:r>
-              <a:rPr lang="en-US" sz="1300" dirty="0">
-                <a:solidFill>
-                  <a:srgbClr val="6B7280"/>
-                </a:solidFill>
-                <a:latin typeface="NanumGothic" pitchFamily="34" charset="0"/>
-                <a:ea typeface="NanumGothic" pitchFamily="34" charset="-122"/>
-                <a:cs typeface="NanumGothic" pitchFamily="34" charset="-120"/>
-              </a:rPr>
-              <a:t> </a:t>
-            </a:r>
-            <a:r>
-              <a:rPr lang="en-US" sz="1300" dirty="0" err="1">
-                <a:solidFill>
-                  <a:srgbClr val="6B7280"/>
-                </a:solidFill>
-                <a:latin typeface="NanumGothic" pitchFamily="34" charset="0"/>
-                <a:ea typeface="NanumGothic" pitchFamily="34" charset="-122"/>
-                <a:cs typeface="NanumGothic" pitchFamily="34" charset="-120"/>
-              </a:rPr>
-              <a:t>고유</a:t>
-            </a:r>
-            <a:r>
-              <a:rPr lang="en-US" sz="1300" dirty="0">
-                <a:solidFill>
-                  <a:srgbClr val="6B7280"/>
-                </a:solidFill>
-                <a:latin typeface="NanumGothic" pitchFamily="34" charset="0"/>
-                <a:ea typeface="NanumGothic" pitchFamily="34" charset="-122"/>
-                <a:cs typeface="NanumGothic" pitchFamily="34" charset="-120"/>
-              </a:rPr>
-              <a:t> 역량</a:t>
+              <a:t>AI 시대에도 변하지 않는 PM의 4가지 고유 역량</a:t>
             </a:r>
             <a:endParaRPr lang="en-US" sz="1300" dirty="0"/>
           </a:p>
@@ -22494,14 +23162,14 @@
           <p:nvPr>
             <p:extLst>
               <p:ext uri="{D42A27DB-BD31-4B8C-83A1-F6EECF244321}">
-                <p14:modId xmlns:p14="http://schemas.microsoft.com/office/powerpoint/2010/main" val="3193678489"/>
+                <p14:modId xmlns:p14="http://schemas.microsoft.com/office/powerpoint/2010/main" val="1579011935"/>
               </p:ext>
             </p:extLst>
           </p:nvPr>
         </p:nvGraphicFramePr>
         <p:xfrm>
-          <a:off x="1097280" y="1698700"/>
-          <a:ext cx="6949440" cy="1417320"/>
+          <a:off x="1097280" y="1097280"/>
+          <a:ext cx="6949440" cy="914400"/>
         </p:xfrm>
         <a:graphic>
           <a:graphicData uri="http://schemas.openxmlformats.org/drawingml/2006/table">
@@ -23351,7 +24019,7 @@
         </p:nvSpPr>
         <p:spPr>
           <a:xfrm>
-            <a:off x="640080" y="3161740"/>
+            <a:off x="640080" y="2560320"/>
             <a:ext cx="7863840" cy="457200"/>
           </a:xfrm>
           <a:prstGeom prst="rect">
@@ -23797,7 +24465,7 @@
         </p:nvSpPr>
         <p:spPr>
           <a:xfrm>
-            <a:off x="640080" y="1634568"/>
+            <a:off x="640080" y="1051560"/>
             <a:ext cx="457200" cy="502920"/>
           </a:xfrm>
           <a:prstGeom prst="rect">
@@ -23824,7 +24492,7 @@
         </p:nvSpPr>
         <p:spPr>
           <a:xfrm>
-            <a:off x="640080" y="1634568"/>
+            <a:off x="640080" y="1051560"/>
             <a:ext cx="457200" cy="502920"/>
           </a:xfrm>
           <a:prstGeom prst="rect">
@@ -23863,7 +24531,7 @@
         </p:nvSpPr>
         <p:spPr>
           <a:xfrm>
-            <a:off x="1280160" y="1634568"/>
+            <a:off x="1280160" y="1051560"/>
             <a:ext cx="2011680" cy="502920"/>
           </a:xfrm>
           <a:prstGeom prst="rect">
@@ -23902,7 +24570,7 @@
         </p:nvSpPr>
         <p:spPr>
           <a:xfrm>
-            <a:off x="3383280" y="1634568"/>
+            <a:off x="3383280" y="1051560"/>
             <a:ext cx="5120640" cy="502920"/>
           </a:xfrm>
           <a:prstGeom prst="rect">
@@ -23964,7 +24632,7 @@
         </p:nvSpPr>
         <p:spPr>
           <a:xfrm>
-            <a:off x="1280160" y="2183208"/>
+            <a:off x="1280160" y="1600200"/>
             <a:ext cx="7223760" cy="9144"/>
           </a:xfrm>
           <a:prstGeom prst="rect">
@@ -23991,7 +24659,7 @@
         </p:nvSpPr>
         <p:spPr>
           <a:xfrm>
-            <a:off x="640080" y="2292936"/>
+            <a:off x="640080" y="1709928"/>
             <a:ext cx="457200" cy="502920"/>
           </a:xfrm>
           <a:prstGeom prst="rect">
@@ -24018,7 +24686,7 @@
         </p:nvSpPr>
         <p:spPr>
           <a:xfrm>
-            <a:off x="640080" y="2292936"/>
+            <a:off x="640080" y="1709928"/>
             <a:ext cx="457200" cy="502920"/>
           </a:xfrm>
           <a:prstGeom prst="rect">
@@ -24057,7 +24725,7 @@
         </p:nvSpPr>
         <p:spPr>
           <a:xfrm>
-            <a:off x="1280160" y="2292936"/>
+            <a:off x="1280160" y="1709928"/>
             <a:ext cx="2011680" cy="502920"/>
           </a:xfrm>
           <a:prstGeom prst="rect">
@@ -24096,7 +24764,7 @@
         </p:nvSpPr>
         <p:spPr>
           <a:xfrm>
-            <a:off x="3383280" y="2292936"/>
+            <a:off x="3383280" y="1709928"/>
             <a:ext cx="5120640" cy="502920"/>
           </a:xfrm>
           <a:prstGeom prst="rect">
@@ -24158,7 +24826,7 @@
         </p:nvSpPr>
         <p:spPr>
           <a:xfrm>
-            <a:off x="1280160" y="2841576"/>
+            <a:off x="1280160" y="2258568"/>
             <a:ext cx="7223760" cy="9144"/>
           </a:xfrm>
           <a:prstGeom prst="rect">
@@ -24185,7 +24853,7 @@
         </p:nvSpPr>
         <p:spPr>
           <a:xfrm>
-            <a:off x="640080" y="2951304"/>
+            <a:off x="640080" y="2368296"/>
             <a:ext cx="457200" cy="502920"/>
           </a:xfrm>
           <a:prstGeom prst="rect">
@@ -24212,7 +24880,7 @@
         </p:nvSpPr>
         <p:spPr>
           <a:xfrm>
-            <a:off x="640080" y="2951304"/>
+            <a:off x="640080" y="2368296"/>
             <a:ext cx="457200" cy="502920"/>
           </a:xfrm>
           <a:prstGeom prst="rect">
@@ -24251,7 +24919,7 @@
         </p:nvSpPr>
         <p:spPr>
           <a:xfrm>
-            <a:off x="1280160" y="2951304"/>
+            <a:off x="1280160" y="2368296"/>
             <a:ext cx="2011680" cy="502920"/>
           </a:xfrm>
           <a:prstGeom prst="rect">
@@ -24290,7 +24958,7 @@
         </p:nvSpPr>
         <p:spPr>
           <a:xfrm>
-            <a:off x="3383280" y="2951304"/>
+            <a:off x="3383280" y="2368296"/>
             <a:ext cx="5120640" cy="502920"/>
           </a:xfrm>
           <a:prstGeom prst="rect">
@@ -24352,7 +25020,7 @@
         </p:nvSpPr>
         <p:spPr>
           <a:xfrm>
-            <a:off x="1280160" y="3499944"/>
+            <a:off x="1280160" y="2916936"/>
             <a:ext cx="7223760" cy="9144"/>
           </a:xfrm>
           <a:prstGeom prst="rect">
@@ -24379,7 +25047,7 @@
         </p:nvSpPr>
         <p:spPr>
           <a:xfrm>
-            <a:off x="640080" y="3609672"/>
+            <a:off x="640080" y="3026664"/>
             <a:ext cx="457200" cy="502920"/>
           </a:xfrm>
           <a:prstGeom prst="rect">
@@ -24406,7 +25074,7 @@
         </p:nvSpPr>
         <p:spPr>
           <a:xfrm>
-            <a:off x="640080" y="3609672"/>
+            <a:off x="640080" y="3026664"/>
             <a:ext cx="457200" cy="502920"/>
           </a:xfrm>
           <a:prstGeom prst="rect">
@@ -24445,7 +25113,7 @@
         </p:nvSpPr>
         <p:spPr>
           <a:xfrm>
-            <a:off x="1280160" y="3609672"/>
+            <a:off x="1280160" y="3026664"/>
             <a:ext cx="2011680" cy="502920"/>
           </a:xfrm>
           <a:prstGeom prst="rect">
@@ -24484,7 +25152,7 @@
         </p:nvSpPr>
         <p:spPr>
           <a:xfrm>
-            <a:off x="3383280" y="3609672"/>
+            <a:off x="3383280" y="3026664"/>
             <a:ext cx="5120640" cy="502920"/>
           </a:xfrm>
           <a:prstGeom prst="rect">
@@ -26291,7 +26959,7 @@
         </p:nvSpPr>
         <p:spPr>
           <a:xfrm>
-            <a:off x="640080" y="1348897"/>
+            <a:off x="640080" y="1097280"/>
             <a:ext cx="7863840" cy="320040"/>
           </a:xfrm>
           <a:prstGeom prst="rect">
@@ -26334,14 +27002,14 @@
           <p:nvPr>
             <p:extLst>
               <p:ext uri="{D42A27DB-BD31-4B8C-83A1-F6EECF244321}">
-                <p14:modId xmlns:p14="http://schemas.microsoft.com/office/powerpoint/2010/main" val="2748482170"/>
+                <p14:modId xmlns:p14="http://schemas.microsoft.com/office/powerpoint/2010/main" val="1579011935"/>
               </p:ext>
             </p:extLst>
           </p:nvPr>
         </p:nvGraphicFramePr>
         <p:xfrm>
-          <a:off x="457200" y="1303177"/>
-          <a:ext cx="8229600" cy="1874520"/>
+          <a:off x="457200" y="1051560"/>
+          <a:ext cx="8229600" cy="914400"/>
         </p:xfrm>
         <a:graphic>
           <a:graphicData uri="http://schemas.openxmlformats.org/drawingml/2006/table">
@@ -27199,7 +27867,7 @@
         </p:nvSpPr>
         <p:spPr>
           <a:xfrm>
-            <a:off x="640080" y="3452017"/>
+            <a:off x="640080" y="3200400"/>
             <a:ext cx="7863840" cy="502920"/>
           </a:xfrm>
           <a:prstGeom prst="rect">
@@ -27226,7 +27894,7 @@
         </p:nvSpPr>
         <p:spPr>
           <a:xfrm>
-            <a:off x="640080" y="3452017"/>
+            <a:off x="640080" y="3200400"/>
             <a:ext cx="36576" cy="502920"/>
           </a:xfrm>
           <a:prstGeom prst="rect">
@@ -27253,7 +27921,7 @@
         </p:nvSpPr>
         <p:spPr>
           <a:xfrm>
-            <a:off x="822960" y="3452017"/>
+            <a:off x="822960" y="3200400"/>
             <a:ext cx="7589520" cy="502920"/>
           </a:xfrm>
           <a:prstGeom prst="rect">

</xml_diff>